<commit_message>
chore: update blockchain data and enhance Q&A features
- Updated lastUpdated, currentBlock, and totalTransactionsRecorded values in chain_data.json to reflect the latest blockchain state.
- Added new transaction logs in transactions_log.json for improved tracking of blockchain events.
- Enhanced Q&A page with moderation features, including academic verification and user feedback on question submissions.
- Updated styling for moderation messages in QA.css to improve user experience.
</commit_message>
<xml_diff>
--- a/Documentation/QChat_Presentation.pptx
+++ b/Documentation/QChat_Presentation.pptx
@@ -1,21 +1,21 @@
 
 <file path=ppt/presentation.xml><?xml version="1.0" encoding="utf-8"?>
-<p:presentation xmlns:a="http://schemas.openxmlformats.org/drawingml/2006/main" xmlns:r="http://schemas.openxmlformats.org/officeDocument/2006/relationships" xmlns:p="http://schemas.openxmlformats.org/presentationml/2006/main" saveSubsetFonts="1" autoCompressPictures="0">
+<p:presentation xmlns:a="http://schemas.openxmlformats.org/drawingml/2006/main" xmlns:r="http://schemas.openxmlformats.org/officeDocument/2006/relationships" xmlns:p="http://schemas.openxmlformats.org/presentationml/2006/main" autoCompressPictures="0">
   <p:sldMasterIdLst>
     <p:sldMasterId id="2147483648" r:id="rId1"/>
   </p:sldMasterIdLst>
   <p:sldIdLst>
-    <p:sldId id="256" r:id="rId2"/>
-    <p:sldId id="257" r:id="rId3"/>
-    <p:sldId id="258" r:id="rId4"/>
-    <p:sldId id="259" r:id="rId5"/>
-    <p:sldId id="260" r:id="rId6"/>
-    <p:sldId id="261" r:id="rId7"/>
-    <p:sldId id="262" r:id="rId8"/>
-    <p:sldId id="263" r:id="rId9"/>
-    <p:sldId id="264" r:id="rId10"/>
-    <p:sldId id="265" r:id="rId11"/>
-    <p:sldId id="266" r:id="rId12"/>
+    <p:sldId id="256" r:id="rId3"/>
+    <p:sldId id="257" r:id="rId4"/>
+    <p:sldId id="258" r:id="rId5"/>
+    <p:sldId id="259" r:id="rId6"/>
+    <p:sldId id="260" r:id="rId7"/>
+    <p:sldId id="261" r:id="rId8"/>
+    <p:sldId id="262" r:id="rId9"/>
+    <p:sldId id="263" r:id="rId10"/>
+    <p:sldId id="264" r:id="rId11"/>
+    <p:sldId id="265" r:id="rId12"/>
+    <p:sldId id="266" r:id="rId13"/>
   </p:sldIdLst>
   <p:sldSz cx="12192000" cy="6858000"/>
   <p:notesSz cx="6858000" cy="9144000"/>
@@ -114,22 +114,6 @@
       </a:defRPr>
     </a:lvl9pPr>
   </p:defaultTextStyle>
-  <p:extLst>
-    <p:ext uri="{EFAFB233-063F-42B5-8137-9DF3F51BA10A}">
-      <p15:sldGuideLst xmlns:p15="http://schemas.microsoft.com/office/powerpoint/2012/main">
-        <p15:guide id="1" orient="horz" pos="2160">
-          <p15:clr>
-            <a:srgbClr val="A4A3A4"/>
-          </p15:clr>
-        </p15:guide>
-        <p15:guide id="2" pos="2880">
-          <p15:clr>
-            <a:srgbClr val="A4A3A4"/>
-          </p15:clr>
-        </p15:guide>
-      </p15:sldGuideLst>
-    </p:ext>
-  </p:extLst>
 </p:presentation>
 </file>
 
@@ -174,6 +158,7 @@
               <a:rPr lang="en-US"/>
               <a:t>Click to edit Master title style</a:t>
             </a:r>
+            <a:endParaRPr lang="en-US"/>
           </a:p>
         </p:txBody>
       </p:sp>
@@ -292,6 +277,7 @@
               <a:rPr lang="en-US"/>
               <a:t>Click to edit Master subtitle style</a:t>
             </a:r>
+            <a:endParaRPr lang="en-US"/>
           </a:p>
         </p:txBody>
       </p:sp>
@@ -312,7 +298,6 @@
           <a:p>
             <a:fld id="{5BCAD085-E8A6-8845-BD4E-CB4CCA059FC4}" type="datetimeFigureOut">
               <a:rPr lang="en-US" smtClean="0"/>
-              <a:t>9/11/2026</a:t>
             </a:fld>
             <a:endParaRPr lang="en-US"/>
           </a:p>
@@ -354,18 +339,12 @@
           <a:p>
             <a:fld id="{C1FF6DA9-008F-8B48-92A6-B652298478BF}" type="slidenum">
               <a:rPr lang="en-US" smtClean="0"/>
-              <a:t>‹#›</a:t>
             </a:fld>
             <a:endParaRPr lang="en-US"/>
           </a:p>
         </p:txBody>
       </p:sp>
     </p:spTree>
-    <p:extLst>
-      <p:ext uri="{BB962C8B-B14F-4D97-AF65-F5344CB8AC3E}">
-        <p14:creationId xmlns:p14="http://schemas.microsoft.com/office/powerpoint/2010/main" val="3168075583"/>
-      </p:ext>
-    </p:extLst>
   </p:cSld>
   <p:clrMapOvr>
     <a:masterClrMapping/>
@@ -409,6 +388,7 @@
               <a:rPr lang="en-US"/>
               <a:t>Click to edit Master title style</a:t>
             </a:r>
+            <a:endParaRPr lang="en-US"/>
           </a:p>
         </p:txBody>
       </p:sp>
@@ -432,6 +412,7 @@
               <a:rPr lang="en-US"/>
               <a:t>Click to edit Master text styles</a:t>
             </a:r>
+            <a:endParaRPr lang="en-US"/>
           </a:p>
           <a:p>
             <a:pPr lvl="1"/>
@@ -439,6 +420,7 @@
               <a:rPr lang="en-US"/>
               <a:t>Second level</a:t>
             </a:r>
+            <a:endParaRPr lang="en-US"/>
           </a:p>
           <a:p>
             <a:pPr lvl="2"/>
@@ -446,6 +428,7 @@
               <a:rPr lang="en-US"/>
               <a:t>Third level</a:t>
             </a:r>
+            <a:endParaRPr lang="en-US"/>
           </a:p>
           <a:p>
             <a:pPr lvl="3"/>
@@ -453,6 +436,7 @@
               <a:rPr lang="en-US"/>
               <a:t>Fourth level</a:t>
             </a:r>
+            <a:endParaRPr lang="en-US"/>
           </a:p>
           <a:p>
             <a:pPr lvl="4"/>
@@ -460,6 +444,7 @@
               <a:rPr lang="en-US"/>
               <a:t>Fifth level</a:t>
             </a:r>
+            <a:endParaRPr lang="en-US"/>
           </a:p>
         </p:txBody>
       </p:sp>
@@ -480,7 +465,6 @@
           <a:p>
             <a:fld id="{5BCAD085-E8A6-8845-BD4E-CB4CCA059FC4}" type="datetimeFigureOut">
               <a:rPr lang="en-US" smtClean="0"/>
-              <a:t>9/11/2026</a:t>
             </a:fld>
             <a:endParaRPr lang="en-US"/>
           </a:p>
@@ -522,18 +506,12 @@
           <a:p>
             <a:fld id="{C1FF6DA9-008F-8B48-92A6-B652298478BF}" type="slidenum">
               <a:rPr lang="en-US" smtClean="0"/>
-              <a:t>‹#›</a:t>
             </a:fld>
             <a:endParaRPr lang="en-US"/>
           </a:p>
         </p:txBody>
       </p:sp>
     </p:spTree>
-    <p:extLst>
-      <p:ext uri="{BB962C8B-B14F-4D97-AF65-F5344CB8AC3E}">
-        <p14:creationId xmlns:p14="http://schemas.microsoft.com/office/powerpoint/2010/main" val="2910927964"/>
-      </p:ext>
-    </p:extLst>
   </p:cSld>
   <p:clrMapOvr>
     <a:masterClrMapping/>
@@ -582,6 +560,7 @@
               <a:rPr lang="en-US"/>
               <a:t>Click to edit Master title style</a:t>
             </a:r>
+            <a:endParaRPr lang="en-US"/>
           </a:p>
         </p:txBody>
       </p:sp>
@@ -610,6 +589,7 @@
               <a:rPr lang="en-US"/>
               <a:t>Click to edit Master text styles</a:t>
             </a:r>
+            <a:endParaRPr lang="en-US"/>
           </a:p>
           <a:p>
             <a:pPr lvl="1"/>
@@ -617,6 +597,7 @@
               <a:rPr lang="en-US"/>
               <a:t>Second level</a:t>
             </a:r>
+            <a:endParaRPr lang="en-US"/>
           </a:p>
           <a:p>
             <a:pPr lvl="2"/>
@@ -624,6 +605,7 @@
               <a:rPr lang="en-US"/>
               <a:t>Third level</a:t>
             </a:r>
+            <a:endParaRPr lang="en-US"/>
           </a:p>
           <a:p>
             <a:pPr lvl="3"/>
@@ -631,6 +613,7 @@
               <a:rPr lang="en-US"/>
               <a:t>Fourth level</a:t>
             </a:r>
+            <a:endParaRPr lang="en-US"/>
           </a:p>
           <a:p>
             <a:pPr lvl="4"/>
@@ -638,6 +621,7 @@
               <a:rPr lang="en-US"/>
               <a:t>Fifth level</a:t>
             </a:r>
+            <a:endParaRPr lang="en-US"/>
           </a:p>
         </p:txBody>
       </p:sp>
@@ -658,7 +642,6 @@
           <a:p>
             <a:fld id="{5BCAD085-E8A6-8845-BD4E-CB4CCA059FC4}" type="datetimeFigureOut">
               <a:rPr lang="en-US" smtClean="0"/>
-              <a:t>9/11/2026</a:t>
             </a:fld>
             <a:endParaRPr lang="en-US"/>
           </a:p>
@@ -700,18 +683,12 @@
           <a:p>
             <a:fld id="{C1FF6DA9-008F-8B48-92A6-B652298478BF}" type="slidenum">
               <a:rPr lang="en-US" smtClean="0"/>
-              <a:t>‹#›</a:t>
             </a:fld>
             <a:endParaRPr lang="en-US"/>
           </a:p>
         </p:txBody>
       </p:sp>
     </p:spTree>
-    <p:extLst>
-      <p:ext uri="{BB962C8B-B14F-4D97-AF65-F5344CB8AC3E}">
-        <p14:creationId xmlns:p14="http://schemas.microsoft.com/office/powerpoint/2010/main" val="3612223792"/>
-      </p:ext>
-    </p:extLst>
   </p:cSld>
   <p:clrMapOvr>
     <a:masterClrMapping/>
@@ -755,6 +732,7 @@
               <a:rPr lang="en-US"/>
               <a:t>Click to edit Master title style</a:t>
             </a:r>
+            <a:endParaRPr lang="en-US"/>
           </a:p>
         </p:txBody>
       </p:sp>
@@ -778,6 +756,7 @@
               <a:rPr lang="en-US"/>
               <a:t>Click to edit Master text styles</a:t>
             </a:r>
+            <a:endParaRPr lang="en-US"/>
           </a:p>
           <a:p>
             <a:pPr lvl="1"/>
@@ -785,6 +764,7 @@
               <a:rPr lang="en-US"/>
               <a:t>Second level</a:t>
             </a:r>
+            <a:endParaRPr lang="en-US"/>
           </a:p>
           <a:p>
             <a:pPr lvl="2"/>
@@ -792,6 +772,7 @@
               <a:rPr lang="en-US"/>
               <a:t>Third level</a:t>
             </a:r>
+            <a:endParaRPr lang="en-US"/>
           </a:p>
           <a:p>
             <a:pPr lvl="3"/>
@@ -799,6 +780,7 @@
               <a:rPr lang="en-US"/>
               <a:t>Fourth level</a:t>
             </a:r>
+            <a:endParaRPr lang="en-US"/>
           </a:p>
           <a:p>
             <a:pPr lvl="4"/>
@@ -806,6 +788,7 @@
               <a:rPr lang="en-US"/>
               <a:t>Fifth level</a:t>
             </a:r>
+            <a:endParaRPr lang="en-US"/>
           </a:p>
         </p:txBody>
       </p:sp>
@@ -826,7 +809,6 @@
           <a:p>
             <a:fld id="{5BCAD085-E8A6-8845-BD4E-CB4CCA059FC4}" type="datetimeFigureOut">
               <a:rPr lang="en-US" smtClean="0"/>
-              <a:t>9/11/2026</a:t>
             </a:fld>
             <a:endParaRPr lang="en-US"/>
           </a:p>
@@ -868,18 +850,12 @@
           <a:p>
             <a:fld id="{C1FF6DA9-008F-8B48-92A6-B652298478BF}" type="slidenum">
               <a:rPr lang="en-US" smtClean="0"/>
-              <a:t>‹#›</a:t>
             </a:fld>
             <a:endParaRPr lang="en-US"/>
           </a:p>
         </p:txBody>
       </p:sp>
     </p:spTree>
-    <p:extLst>
-      <p:ext uri="{BB962C8B-B14F-4D97-AF65-F5344CB8AC3E}">
-        <p14:creationId xmlns:p14="http://schemas.microsoft.com/office/powerpoint/2010/main" val="2614314258"/>
-      </p:ext>
-    </p:extLst>
   </p:cSld>
   <p:clrMapOvr>
     <a:masterClrMapping/>
@@ -932,6 +908,7 @@
               <a:rPr lang="en-US"/>
               <a:t>Click to edit Master title style</a:t>
             </a:r>
+            <a:endParaRPr lang="en-US"/>
           </a:p>
         </p:txBody>
       </p:sp>
@@ -1051,6 +1028,7 @@
               <a:rPr lang="en-US"/>
               <a:t>Click to edit Master text styles</a:t>
             </a:r>
+            <a:endParaRPr lang="en-US"/>
           </a:p>
         </p:txBody>
       </p:sp>
@@ -1071,7 +1049,6 @@
           <a:p>
             <a:fld id="{5BCAD085-E8A6-8845-BD4E-CB4CCA059FC4}" type="datetimeFigureOut">
               <a:rPr lang="en-US" smtClean="0"/>
-              <a:t>9/11/2026</a:t>
             </a:fld>
             <a:endParaRPr lang="en-US"/>
           </a:p>
@@ -1113,18 +1090,12 @@
           <a:p>
             <a:fld id="{C1FF6DA9-008F-8B48-92A6-B652298478BF}" type="slidenum">
               <a:rPr lang="en-US" smtClean="0"/>
-              <a:t>‹#›</a:t>
             </a:fld>
             <a:endParaRPr lang="en-US"/>
           </a:p>
         </p:txBody>
       </p:sp>
     </p:spTree>
-    <p:extLst>
-      <p:ext uri="{BB962C8B-B14F-4D97-AF65-F5344CB8AC3E}">
-        <p14:creationId xmlns:p14="http://schemas.microsoft.com/office/powerpoint/2010/main" val="960648375"/>
-      </p:ext>
-    </p:extLst>
   </p:cSld>
   <p:clrMapOvr>
     <a:masterClrMapping/>
@@ -1168,6 +1139,7 @@
               <a:rPr lang="en-US"/>
               <a:t>Click to edit Master title style</a:t>
             </a:r>
+            <a:endParaRPr lang="en-US"/>
           </a:p>
         </p:txBody>
       </p:sp>
@@ -1224,6 +1196,7 @@
               <a:rPr lang="en-US"/>
               <a:t>Click to edit Master text styles</a:t>
             </a:r>
+            <a:endParaRPr lang="en-US"/>
           </a:p>
           <a:p>
             <a:pPr lvl="1"/>
@@ -1231,6 +1204,7 @@
               <a:rPr lang="en-US"/>
               <a:t>Second level</a:t>
             </a:r>
+            <a:endParaRPr lang="en-US"/>
           </a:p>
           <a:p>
             <a:pPr lvl="2"/>
@@ -1238,6 +1212,7 @@
               <a:rPr lang="en-US"/>
               <a:t>Third level</a:t>
             </a:r>
+            <a:endParaRPr lang="en-US"/>
           </a:p>
           <a:p>
             <a:pPr lvl="3"/>
@@ -1245,6 +1220,7 @@
               <a:rPr lang="en-US"/>
               <a:t>Fourth level</a:t>
             </a:r>
+            <a:endParaRPr lang="en-US"/>
           </a:p>
           <a:p>
             <a:pPr lvl="4"/>
@@ -1252,6 +1228,7 @@
               <a:rPr lang="en-US"/>
               <a:t>Fifth level</a:t>
             </a:r>
+            <a:endParaRPr lang="en-US"/>
           </a:p>
         </p:txBody>
       </p:sp>
@@ -1308,6 +1285,7 @@
               <a:rPr lang="en-US"/>
               <a:t>Click to edit Master text styles</a:t>
             </a:r>
+            <a:endParaRPr lang="en-US"/>
           </a:p>
           <a:p>
             <a:pPr lvl="1"/>
@@ -1315,6 +1293,7 @@
               <a:rPr lang="en-US"/>
               <a:t>Second level</a:t>
             </a:r>
+            <a:endParaRPr lang="en-US"/>
           </a:p>
           <a:p>
             <a:pPr lvl="2"/>
@@ -1322,6 +1301,7 @@
               <a:rPr lang="en-US"/>
               <a:t>Third level</a:t>
             </a:r>
+            <a:endParaRPr lang="en-US"/>
           </a:p>
           <a:p>
             <a:pPr lvl="3"/>
@@ -1329,6 +1309,7 @@
               <a:rPr lang="en-US"/>
               <a:t>Fourth level</a:t>
             </a:r>
+            <a:endParaRPr lang="en-US"/>
           </a:p>
           <a:p>
             <a:pPr lvl="4"/>
@@ -1336,6 +1317,7 @@
               <a:rPr lang="en-US"/>
               <a:t>Fifth level</a:t>
             </a:r>
+            <a:endParaRPr lang="en-US"/>
           </a:p>
         </p:txBody>
       </p:sp>
@@ -1356,7 +1338,6 @@
           <a:p>
             <a:fld id="{5BCAD085-E8A6-8845-BD4E-CB4CCA059FC4}" type="datetimeFigureOut">
               <a:rPr lang="en-US" smtClean="0"/>
-              <a:t>9/11/2026</a:t>
             </a:fld>
             <a:endParaRPr lang="en-US"/>
           </a:p>
@@ -1398,18 +1379,12 @@
           <a:p>
             <a:fld id="{C1FF6DA9-008F-8B48-92A6-B652298478BF}" type="slidenum">
               <a:rPr lang="en-US" smtClean="0"/>
-              <a:t>‹#›</a:t>
             </a:fld>
             <a:endParaRPr lang="en-US"/>
           </a:p>
         </p:txBody>
       </p:sp>
     </p:spTree>
-    <p:extLst>
-      <p:ext uri="{BB962C8B-B14F-4D97-AF65-F5344CB8AC3E}">
-        <p14:creationId xmlns:p14="http://schemas.microsoft.com/office/powerpoint/2010/main" val="2782244947"/>
-      </p:ext>
-    </p:extLst>
   </p:cSld>
   <p:clrMapOvr>
     <a:masterClrMapping/>
@@ -1457,6 +1432,7 @@
               <a:rPr lang="en-US"/>
               <a:t>Click to edit Master title style</a:t>
             </a:r>
+            <a:endParaRPr lang="en-US"/>
           </a:p>
         </p:txBody>
       </p:sp>
@@ -1522,6 +1498,7 @@
               <a:rPr lang="en-US"/>
               <a:t>Click to edit Master text styles</a:t>
             </a:r>
+            <a:endParaRPr lang="en-US"/>
           </a:p>
         </p:txBody>
       </p:sp>
@@ -1578,6 +1555,7 @@
               <a:rPr lang="en-US"/>
               <a:t>Click to edit Master text styles</a:t>
             </a:r>
+            <a:endParaRPr lang="en-US"/>
           </a:p>
           <a:p>
             <a:pPr lvl="1"/>
@@ -1585,6 +1563,7 @@
               <a:rPr lang="en-US"/>
               <a:t>Second level</a:t>
             </a:r>
+            <a:endParaRPr lang="en-US"/>
           </a:p>
           <a:p>
             <a:pPr lvl="2"/>
@@ -1592,6 +1571,7 @@
               <a:rPr lang="en-US"/>
               <a:t>Third level</a:t>
             </a:r>
+            <a:endParaRPr lang="en-US"/>
           </a:p>
           <a:p>
             <a:pPr lvl="3"/>
@@ -1599,6 +1579,7 @@
               <a:rPr lang="en-US"/>
               <a:t>Fourth level</a:t>
             </a:r>
+            <a:endParaRPr lang="en-US"/>
           </a:p>
           <a:p>
             <a:pPr lvl="4"/>
@@ -1606,6 +1587,7 @@
               <a:rPr lang="en-US"/>
               <a:t>Fifth level</a:t>
             </a:r>
+            <a:endParaRPr lang="en-US"/>
           </a:p>
         </p:txBody>
       </p:sp>
@@ -1671,6 +1653,7 @@
               <a:rPr lang="en-US"/>
               <a:t>Click to edit Master text styles</a:t>
             </a:r>
+            <a:endParaRPr lang="en-US"/>
           </a:p>
         </p:txBody>
       </p:sp>
@@ -1727,6 +1710,7 @@
               <a:rPr lang="en-US"/>
               <a:t>Click to edit Master text styles</a:t>
             </a:r>
+            <a:endParaRPr lang="en-US"/>
           </a:p>
           <a:p>
             <a:pPr lvl="1"/>
@@ -1734,6 +1718,7 @@
               <a:rPr lang="en-US"/>
               <a:t>Second level</a:t>
             </a:r>
+            <a:endParaRPr lang="en-US"/>
           </a:p>
           <a:p>
             <a:pPr lvl="2"/>
@@ -1741,6 +1726,7 @@
               <a:rPr lang="en-US"/>
               <a:t>Third level</a:t>
             </a:r>
+            <a:endParaRPr lang="en-US"/>
           </a:p>
           <a:p>
             <a:pPr lvl="3"/>
@@ -1748,6 +1734,7 @@
               <a:rPr lang="en-US"/>
               <a:t>Fourth level</a:t>
             </a:r>
+            <a:endParaRPr lang="en-US"/>
           </a:p>
           <a:p>
             <a:pPr lvl="4"/>
@@ -1755,6 +1742,7 @@
               <a:rPr lang="en-US"/>
               <a:t>Fifth level</a:t>
             </a:r>
+            <a:endParaRPr lang="en-US"/>
           </a:p>
         </p:txBody>
       </p:sp>
@@ -1775,7 +1763,6 @@
           <a:p>
             <a:fld id="{5BCAD085-E8A6-8845-BD4E-CB4CCA059FC4}" type="datetimeFigureOut">
               <a:rPr lang="en-US" smtClean="0"/>
-              <a:t>9/11/2026</a:t>
             </a:fld>
             <a:endParaRPr lang="en-US"/>
           </a:p>
@@ -1817,18 +1804,12 @@
           <a:p>
             <a:fld id="{C1FF6DA9-008F-8B48-92A6-B652298478BF}" type="slidenum">
               <a:rPr lang="en-US" smtClean="0"/>
-              <a:t>‹#›</a:t>
             </a:fld>
             <a:endParaRPr lang="en-US"/>
           </a:p>
         </p:txBody>
       </p:sp>
     </p:spTree>
-    <p:extLst>
-      <p:ext uri="{BB962C8B-B14F-4D97-AF65-F5344CB8AC3E}">
-        <p14:creationId xmlns:p14="http://schemas.microsoft.com/office/powerpoint/2010/main" val="990158736"/>
-      </p:ext>
-    </p:extLst>
   </p:cSld>
   <p:clrMapOvr>
     <a:masterClrMapping/>
@@ -1872,6 +1853,7 @@
               <a:rPr lang="en-US"/>
               <a:t>Click to edit Master title style</a:t>
             </a:r>
+            <a:endParaRPr lang="en-US"/>
           </a:p>
         </p:txBody>
       </p:sp>
@@ -1892,7 +1874,6 @@
           <a:p>
             <a:fld id="{5BCAD085-E8A6-8845-BD4E-CB4CCA059FC4}" type="datetimeFigureOut">
               <a:rPr lang="en-US" smtClean="0"/>
-              <a:t>9/11/2026</a:t>
             </a:fld>
             <a:endParaRPr lang="en-US"/>
           </a:p>
@@ -1934,18 +1915,12 @@
           <a:p>
             <a:fld id="{C1FF6DA9-008F-8B48-92A6-B652298478BF}" type="slidenum">
               <a:rPr lang="en-US" smtClean="0"/>
-              <a:t>‹#›</a:t>
             </a:fld>
             <a:endParaRPr lang="en-US"/>
           </a:p>
         </p:txBody>
       </p:sp>
     </p:spTree>
-    <p:extLst>
-      <p:ext uri="{BB962C8B-B14F-4D97-AF65-F5344CB8AC3E}">
-        <p14:creationId xmlns:p14="http://schemas.microsoft.com/office/powerpoint/2010/main" val="727027711"/>
-      </p:ext>
-    </p:extLst>
   </p:cSld>
   <p:clrMapOvr>
     <a:masterClrMapping/>
@@ -1987,7 +1962,6 @@
           <a:p>
             <a:fld id="{5BCAD085-E8A6-8845-BD4E-CB4CCA059FC4}" type="datetimeFigureOut">
               <a:rPr lang="en-US" smtClean="0"/>
-              <a:t>9/11/2026</a:t>
             </a:fld>
             <a:endParaRPr lang="en-US"/>
           </a:p>
@@ -2029,18 +2003,12 @@
           <a:p>
             <a:fld id="{C1FF6DA9-008F-8B48-92A6-B652298478BF}" type="slidenum">
               <a:rPr lang="en-US" smtClean="0"/>
-              <a:t>‹#›</a:t>
             </a:fld>
             <a:endParaRPr lang="en-US"/>
           </a:p>
         </p:txBody>
       </p:sp>
     </p:spTree>
-    <p:extLst>
-      <p:ext uri="{BB962C8B-B14F-4D97-AF65-F5344CB8AC3E}">
-        <p14:creationId xmlns:p14="http://schemas.microsoft.com/office/powerpoint/2010/main" val="1212999818"/>
-      </p:ext>
-    </p:extLst>
   </p:cSld>
   <p:clrMapOvr>
     <a:masterClrMapping/>
@@ -2093,6 +2061,7 @@
               <a:rPr lang="en-US"/>
               <a:t>Click to edit Master title style</a:t>
             </a:r>
+            <a:endParaRPr lang="en-US"/>
           </a:p>
         </p:txBody>
       </p:sp>
@@ -2149,6 +2118,7 @@
               <a:rPr lang="en-US"/>
               <a:t>Click to edit Master text styles</a:t>
             </a:r>
+            <a:endParaRPr lang="en-US"/>
           </a:p>
           <a:p>
             <a:pPr lvl="1"/>
@@ -2156,6 +2126,7 @@
               <a:rPr lang="en-US"/>
               <a:t>Second level</a:t>
             </a:r>
+            <a:endParaRPr lang="en-US"/>
           </a:p>
           <a:p>
             <a:pPr lvl="2"/>
@@ -2163,6 +2134,7 @@
               <a:rPr lang="en-US"/>
               <a:t>Third level</a:t>
             </a:r>
+            <a:endParaRPr lang="en-US"/>
           </a:p>
           <a:p>
             <a:pPr lvl="3"/>
@@ -2170,6 +2142,7 @@
               <a:rPr lang="en-US"/>
               <a:t>Fourth level</a:t>
             </a:r>
+            <a:endParaRPr lang="en-US"/>
           </a:p>
           <a:p>
             <a:pPr lvl="4"/>
@@ -2177,6 +2150,7 @@
               <a:rPr lang="en-US"/>
               <a:t>Fifth level</a:t>
             </a:r>
+            <a:endParaRPr lang="en-US"/>
           </a:p>
         </p:txBody>
       </p:sp>
@@ -2242,6 +2216,7 @@
               <a:rPr lang="en-US"/>
               <a:t>Click to edit Master text styles</a:t>
             </a:r>
+            <a:endParaRPr lang="en-US"/>
           </a:p>
         </p:txBody>
       </p:sp>
@@ -2262,7 +2237,6 @@
           <a:p>
             <a:fld id="{5BCAD085-E8A6-8845-BD4E-CB4CCA059FC4}" type="datetimeFigureOut">
               <a:rPr lang="en-US" smtClean="0"/>
-              <a:t>9/11/2026</a:t>
             </a:fld>
             <a:endParaRPr lang="en-US"/>
           </a:p>
@@ -2304,18 +2278,12 @@
           <a:p>
             <a:fld id="{C1FF6DA9-008F-8B48-92A6-B652298478BF}" type="slidenum">
               <a:rPr lang="en-US" smtClean="0"/>
-              <a:t>‹#›</a:t>
             </a:fld>
             <a:endParaRPr lang="en-US"/>
           </a:p>
         </p:txBody>
       </p:sp>
     </p:spTree>
-    <p:extLst>
-      <p:ext uri="{BB962C8B-B14F-4D97-AF65-F5344CB8AC3E}">
-        <p14:creationId xmlns:p14="http://schemas.microsoft.com/office/powerpoint/2010/main" val="1840726560"/>
-      </p:ext>
-    </p:extLst>
   </p:cSld>
   <p:clrMapOvr>
     <a:masterClrMapping/>
@@ -2368,6 +2336,7 @@
               <a:rPr lang="en-US"/>
               <a:t>Click to edit Master title style</a:t>
             </a:r>
+            <a:endParaRPr lang="en-US"/>
           </a:p>
         </p:txBody>
       </p:sp>
@@ -2494,6 +2463,7 @@
               <a:rPr lang="en-US"/>
               <a:t>Click to edit Master text styles</a:t>
             </a:r>
+            <a:endParaRPr lang="en-US"/>
           </a:p>
         </p:txBody>
       </p:sp>
@@ -2514,7 +2484,6 @@
           <a:p>
             <a:fld id="{5BCAD085-E8A6-8845-BD4E-CB4CCA059FC4}" type="datetimeFigureOut">
               <a:rPr lang="en-US" smtClean="0"/>
-              <a:t>9/11/2026</a:t>
             </a:fld>
             <a:endParaRPr lang="en-US"/>
           </a:p>
@@ -2556,18 +2525,12 @@
           <a:p>
             <a:fld id="{C1FF6DA9-008F-8B48-92A6-B652298478BF}" type="slidenum">
               <a:rPr lang="en-US" smtClean="0"/>
-              <a:t>‹#›</a:t>
             </a:fld>
             <a:endParaRPr lang="en-US"/>
           </a:p>
         </p:txBody>
       </p:sp>
     </p:spTree>
-    <p:extLst>
-      <p:ext uri="{BB962C8B-B14F-4D97-AF65-F5344CB8AC3E}">
-        <p14:creationId xmlns:p14="http://schemas.microsoft.com/office/powerpoint/2010/main" val="3889236939"/>
-      </p:ext>
-    </p:extLst>
   </p:cSld>
   <p:clrMapOvr>
     <a:masterClrMapping/>
@@ -2626,6 +2589,7 @@
               <a:rPr lang="en-US"/>
               <a:t>Click to edit Master title style</a:t>
             </a:r>
+            <a:endParaRPr lang="en-US"/>
           </a:p>
         </p:txBody>
       </p:sp>
@@ -2659,6 +2623,7 @@
               <a:rPr lang="en-US"/>
               <a:t>Click to edit Master text styles</a:t>
             </a:r>
+            <a:endParaRPr lang="en-US"/>
           </a:p>
           <a:p>
             <a:pPr lvl="1"/>
@@ -2666,6 +2631,7 @@
               <a:rPr lang="en-US"/>
               <a:t>Second level</a:t>
             </a:r>
+            <a:endParaRPr lang="en-US"/>
           </a:p>
           <a:p>
             <a:pPr lvl="2"/>
@@ -2673,6 +2639,7 @@
               <a:rPr lang="en-US"/>
               <a:t>Third level</a:t>
             </a:r>
+            <a:endParaRPr lang="en-US"/>
           </a:p>
           <a:p>
             <a:pPr lvl="3"/>
@@ -2680,6 +2647,7 @@
               <a:rPr lang="en-US"/>
               <a:t>Fourth level</a:t>
             </a:r>
+            <a:endParaRPr lang="en-US"/>
           </a:p>
           <a:p>
             <a:pPr lvl="4"/>
@@ -2687,6 +2655,7 @@
               <a:rPr lang="en-US"/>
               <a:t>Fifth level</a:t>
             </a:r>
+            <a:endParaRPr lang="en-US"/>
           </a:p>
         </p:txBody>
       </p:sp>
@@ -2725,7 +2694,6 @@
           <a:p>
             <a:fld id="{5BCAD085-E8A6-8845-BD4E-CB4CCA059FC4}" type="datetimeFigureOut">
               <a:rPr lang="en-US" smtClean="0"/>
-              <a:t>9/11/2026</a:t>
             </a:fld>
             <a:endParaRPr lang="en-US"/>
           </a:p>
@@ -2803,18 +2771,12 @@
           <a:p>
             <a:fld id="{C1FF6DA9-008F-8B48-92A6-B652298478BF}" type="slidenum">
               <a:rPr lang="en-US" smtClean="0"/>
-              <a:t>‹#›</a:t>
             </a:fld>
             <a:endParaRPr lang="en-US"/>
           </a:p>
         </p:txBody>
       </p:sp>
     </p:spTree>
-    <p:extLst>
-      <p:ext uri="{BB962C8B-B14F-4D97-AF65-F5344CB8AC3E}">
-        <p14:creationId xmlns:p14="http://schemas.microsoft.com/office/powerpoint/2010/main" val="2209977519"/>
-      </p:ext>
-    </p:extLst>
   </p:cSld>
   <p:clrMap bg1="lt1" tx1="dk1" bg2="lt2" tx2="dk2" accent1="accent1" accent2="accent2" accent3="accent3" accent4="accent4" accent5="accent5" accent6="accent6" hlink="hlink" folHlink="folHlink"/>
   <p:sldLayoutIdLst>
@@ -3263,6 +3225,12 @@
               </a:rPr>
               <a:t>UNIVERSITY OF ENERGY AND NATURAL RESOURCES</a:t>
             </a:r>
+            <a:endParaRPr sz="1200" b="1">
+              <a:solidFill>
+                <a:srgbClr val="FFC107"/>
+              </a:solidFill>
+              <a:latin typeface="Calibri"/>
+            </a:endParaRPr>
           </a:p>
           <a:p>
             <a:r>
@@ -3274,6 +3242,12 @@
               </a:rPr>
               <a:t>Department of Computer Science &amp; Informatics</a:t>
             </a:r>
+            <a:endParaRPr sz="1600">
+              <a:solidFill>
+                <a:srgbClr val="BAE6FD"/>
+              </a:solidFill>
+              <a:latin typeface="Calibri"/>
+            </a:endParaRPr>
           </a:p>
           <a:p>
             <a:r>
@@ -3285,6 +3259,12 @@
               </a:rPr>
               <a:t>B.Sc. Computer Science Final Project</a:t>
             </a:r>
+            <a:endParaRPr sz="1200" i="1">
+              <a:solidFill>
+                <a:srgbClr val="FFFFFF"/>
+              </a:solidFill>
+              <a:latin typeface="Calibri"/>
+            </a:endParaRPr>
           </a:p>
         </p:txBody>
       </p:sp>
@@ -3363,6 +3343,12 @@
               </a:rPr>
               <a:t>PROJECT PRESENTERS:</a:t>
             </a:r>
+            <a:endParaRPr sz="1100" b="1" dirty="0">
+              <a:solidFill>
+                <a:srgbClr val="FFC107"/>
+              </a:solidFill>
+              <a:latin typeface="Calibri"/>
+            </a:endParaRPr>
           </a:p>
           <a:p>
             <a:pPr>
@@ -3388,6 +3374,12 @@
               </a:rPr>
               <a:t> Bright Agyei</a:t>
             </a:r>
+            <a:endParaRPr b="1" dirty="0">
+              <a:solidFill>
+                <a:srgbClr val="FFFFFF"/>
+              </a:solidFill>
+              <a:latin typeface="Calibri"/>
+            </a:endParaRPr>
           </a:p>
           <a:p>
             <a:r>
@@ -3399,6 +3391,12 @@
               </a:rPr>
               <a:t>Index No: UEB3501222</a:t>
             </a:r>
+            <a:endParaRPr sz="1200" dirty="0">
+              <a:solidFill>
+                <a:srgbClr val="3FBEF1"/>
+              </a:solidFill>
+              <a:latin typeface="Calibri"/>
+            </a:endParaRPr>
           </a:p>
           <a:p>
             <a:pPr>
@@ -3415,6 +3413,12 @@
               </a:rPr>
               <a:t>Mohammed Idris Adam</a:t>
             </a:r>
+            <a:endParaRPr b="1" dirty="0">
+              <a:solidFill>
+                <a:srgbClr val="FFFFFF"/>
+              </a:solidFill>
+              <a:latin typeface="Calibri"/>
+            </a:endParaRPr>
           </a:p>
           <a:p>
             <a:r>
@@ -3426,6 +3430,12 @@
               </a:rPr>
               <a:t>Index No: UEB3501022</a:t>
             </a:r>
+            <a:endParaRPr sz="1200" dirty="0">
+              <a:solidFill>
+                <a:srgbClr val="3FBEF1"/>
+              </a:solidFill>
+              <a:latin typeface="Calibri"/>
+            </a:endParaRPr>
           </a:p>
           <a:p>
             <a:pPr>
@@ -3460,6 +3470,12 @@
               </a:rPr>
               <a:t> Anang</a:t>
             </a:r>
+            <a:endParaRPr b="1" dirty="0">
+              <a:solidFill>
+                <a:srgbClr val="FFFFFF"/>
+              </a:solidFill>
+              <a:latin typeface="Calibri"/>
+            </a:endParaRPr>
           </a:p>
           <a:p>
             <a:r>
@@ -3471,6 +3487,12 @@
               </a:rPr>
               <a:t>Index No: UEB3512522</a:t>
             </a:r>
+            <a:endParaRPr sz="1200" dirty="0">
+              <a:solidFill>
+                <a:srgbClr val="3FBEF1"/>
+              </a:solidFill>
+              <a:latin typeface="Calibri"/>
+            </a:endParaRPr>
           </a:p>
           <a:p>
             <a:pPr>
@@ -3487,6 +3509,12 @@
               </a:rPr>
               <a:t>Osei Nana Kwaku</a:t>
             </a:r>
+            <a:endParaRPr b="1" dirty="0">
+              <a:solidFill>
+                <a:srgbClr val="FFFFFF"/>
+              </a:solidFill>
+              <a:latin typeface="Calibri"/>
+            </a:endParaRPr>
           </a:p>
           <a:p>
             <a:r>
@@ -3498,6 +3526,12 @@
               </a:rPr>
               <a:t>Index No: UEB3509022</a:t>
             </a:r>
+            <a:endParaRPr sz="1200" dirty="0">
+              <a:solidFill>
+                <a:srgbClr val="3FBEF1"/>
+              </a:solidFill>
+              <a:latin typeface="Calibri"/>
+            </a:endParaRPr>
           </a:p>
           <a:p>
             <a:pPr>
@@ -3542,6 +3576,12 @@
               </a:rPr>
               <a:t> </a:t>
             </a:r>
+            <a:endParaRPr b="1" dirty="0">
+              <a:solidFill>
+                <a:srgbClr val="FFFFFF"/>
+              </a:solidFill>
+              <a:latin typeface="Calibri"/>
+            </a:endParaRPr>
           </a:p>
         </p:txBody>
       </p:sp>
@@ -3576,6 +3616,12 @@
               </a:rPr>
               <a:t>ACADEMIC Q&amp;A &amp; SECURE CONSULTATION PLATFORM</a:t>
             </a:r>
+            <a:endParaRPr sz="1600" b="1" dirty="0">
+              <a:solidFill>
+                <a:srgbClr val="1E90FF"/>
+              </a:solidFill>
+              <a:latin typeface="Calibri"/>
+            </a:endParaRPr>
           </a:p>
           <a:p>
             <a:pPr>
@@ -3601,6 +3647,12 @@
               </a:rPr>
               <a:t> Connect</a:t>
             </a:r>
+            <a:endParaRPr sz="4800" b="1" dirty="0">
+              <a:solidFill>
+                <a:srgbClr val="00336A"/>
+              </a:solidFill>
+              <a:latin typeface="Calibri"/>
+            </a:endParaRPr>
           </a:p>
           <a:p>
             <a:pPr>
@@ -3617,6 +3669,12 @@
               </a:rPr>
               <a:t>A Verified Academic Q&amp;A Forum &amp; Secure Consultation Platform for Higher Education</a:t>
             </a:r>
+            <a:endParaRPr sz="2000" b="1" dirty="0">
+              <a:solidFill>
+                <a:srgbClr val="1E293B"/>
+              </a:solidFill>
+              <a:latin typeface="Calibri"/>
+            </a:endParaRPr>
           </a:p>
           <a:p>
             <a:pPr>
@@ -3633,6 +3691,12 @@
               </a:rPr>
               <a:t>Institutional Case Study &amp; Pilot Deployment: University of Energy and Natural Resources (UENR)</a:t>
             </a:r>
+            <a:endParaRPr i="1" dirty="0">
+              <a:solidFill>
+                <a:srgbClr val="475569"/>
+              </a:solidFill>
+              <a:latin typeface="Calibri"/>
+            </a:endParaRPr>
           </a:p>
         </p:txBody>
       </p:sp>
@@ -3757,6 +3821,12 @@
               </a:rPr>
               <a:t>🏛️ Verified Academic Forum</a:t>
             </a:r>
+            <a:endParaRPr sz="1600" b="1" dirty="0">
+              <a:solidFill>
+                <a:srgbClr val="00336A"/>
+              </a:solidFill>
+              <a:latin typeface="Calibri"/>
+            </a:endParaRPr>
           </a:p>
           <a:p>
             <a:pPr>
@@ -3773,6 +3843,12 @@
               </a:rPr>
               <a:t>Public departmental discussions &amp; faculty Q&amp;A exchange</a:t>
             </a:r>
+            <a:endParaRPr sz="1100" dirty="0">
+              <a:solidFill>
+                <a:srgbClr val="475569"/>
+              </a:solidFill>
+              <a:latin typeface="Calibri"/>
+            </a:endParaRPr>
           </a:p>
         </p:txBody>
       </p:sp>
@@ -3897,6 +3973,12 @@
               </a:rPr>
               <a:t>🛡️ Identity &amp; Field Badges</a:t>
             </a:r>
+            <a:endParaRPr sz="1600" b="1">
+              <a:solidFill>
+                <a:srgbClr val="00336A"/>
+              </a:solidFill>
+              <a:latin typeface="Calibri"/>
+            </a:endParaRPr>
           </a:p>
           <a:p>
             <a:pPr>
@@ -3913,6 +3995,12 @@
               </a:rPr>
               <a:t>Institutional credentials &amp; specialization authority (CS, Crypto)</a:t>
             </a:r>
+            <a:endParaRPr sz="1100">
+              <a:solidFill>
+                <a:srgbClr val="475569"/>
+              </a:solidFill>
+              <a:latin typeface="Calibri"/>
+            </a:endParaRPr>
           </a:p>
         </p:txBody>
       </p:sp>
@@ -4037,6 +4125,12 @@
               </a:rPr>
               <a:t>💬 Encrypted Consultation</a:t>
             </a:r>
+            <a:endParaRPr sz="1600" b="1">
+              <a:solidFill>
+                <a:srgbClr val="00336A"/>
+              </a:solidFill>
+              <a:latin typeface="Calibri"/>
+            </a:endParaRPr>
           </a:p>
           <a:p>
             <a:pPr>
@@ -4053,6 +4147,12 @@
               </a:rPr>
               <a:t>Private 1-on-1 follow-up messaging (RSA-2048 + AES-256)</a:t>
             </a:r>
+            <a:endParaRPr sz="1100">
+              <a:solidFill>
+                <a:srgbClr val="475569"/>
+              </a:solidFill>
+              <a:latin typeface="Calibri"/>
+            </a:endParaRPr>
           </a:p>
         </p:txBody>
       </p:sp>
@@ -4177,6 +4277,12 @@
               </a:rPr>
               <a:t>⛓️ Immutable Blockchain Proof</a:t>
             </a:r>
+            <a:endParaRPr sz="1600" b="1">
+              <a:solidFill>
+                <a:srgbClr val="00336A"/>
+              </a:solidFill>
+              <a:latin typeface="Calibri"/>
+            </a:endParaRPr>
           </a:p>
           <a:p>
             <a:pPr>
@@ -4193,6 +4299,12 @@
               </a:rPr>
               <a:t>Zero-gas Hyperledger Besu audit trail for non-repudiation</a:t>
             </a:r>
+            <a:endParaRPr sz="1100">
+              <a:solidFill>
+                <a:srgbClr val="475569"/>
+              </a:solidFill>
+              <a:latin typeface="Calibri"/>
+            </a:endParaRPr>
           </a:p>
         </p:txBody>
       </p:sp>
@@ -4227,18 +4339,42 @@
               </a:rPr>
               <a:t>September 2026 | Department of Computer Science &amp; Informatics | UENR</a:t>
             </a:r>
+            <a:endParaRPr sz="1200" b="1">
+              <a:solidFill>
+                <a:srgbClr val="475569"/>
+              </a:solidFill>
+              <a:latin typeface="Calibri"/>
+            </a:endParaRPr>
           </a:p>
         </p:txBody>
       </p:sp>
       <p:pic>
         <p:nvPicPr>
-          <p:cNvPr id="23" name="Picture 22">
-            <a:extLst>
-              <a:ext uri="{FF2B5EF4-FFF2-40B4-BE49-F238E27FC236}">
-                <a16:creationId xmlns:a16="http://schemas.microsoft.com/office/drawing/2014/main" id="{372ABCE2-2AFD-382A-670C-BF8D08B4BF07}"/>
-              </a:ext>
-            </a:extLst>
-          </p:cNvPr>
+          <p:cNvPr id="23" name="Picture 22"/>
+          <p:cNvPicPr>
+            <a:picLocks noChangeAspect="1"/>
+          </p:cNvPicPr>
+          <p:nvPr/>
+        </p:nvPicPr>
+        <p:blipFill>
+          <a:blip r:embed="rId1"/>
+          <a:stretch>
+            <a:fillRect/>
+          </a:stretch>
+        </p:blipFill>
+        <p:spPr>
+          <a:xfrm>
+            <a:off x="7355387" y="-40762"/>
+            <a:ext cx="860597" cy="860597"/>
+          </a:xfrm>
+          <a:prstGeom prst="rect">
+            <a:avLst/>
+          </a:prstGeom>
+        </p:spPr>
+      </p:pic>
+      <p:pic>
+        <p:nvPicPr>
+          <p:cNvPr id="25" name="Picture 24"/>
           <p:cNvPicPr>
             <a:picLocks noChangeAspect="1"/>
           </p:cNvPicPr>
@@ -4252,36 +4388,6 @@
         </p:blipFill>
         <p:spPr>
           <a:xfrm>
-            <a:off x="7355387" y="-40762"/>
-            <a:ext cx="860597" cy="860597"/>
-          </a:xfrm>
-          <a:prstGeom prst="rect">
-            <a:avLst/>
-          </a:prstGeom>
-        </p:spPr>
-      </p:pic>
-      <p:pic>
-        <p:nvPicPr>
-          <p:cNvPr id="25" name="Picture 24">
-            <a:extLst>
-              <a:ext uri="{FF2B5EF4-FFF2-40B4-BE49-F238E27FC236}">
-                <a16:creationId xmlns:a16="http://schemas.microsoft.com/office/drawing/2014/main" id="{83C2D359-C0CC-7655-5947-23E2949BB276}"/>
-              </a:ext>
-            </a:extLst>
-          </p:cNvPr>
-          <p:cNvPicPr>
-            <a:picLocks noChangeAspect="1"/>
-          </p:cNvPicPr>
-          <p:nvPr/>
-        </p:nvPicPr>
-        <p:blipFill>
-          <a:blip r:embed="rId3"/>
-          <a:stretch>
-            <a:fillRect/>
-          </a:stretch>
-        </p:blipFill>
-        <p:spPr>
-          <a:xfrm>
             <a:off x="8046720" y="0"/>
             <a:ext cx="902492" cy="819836"/>
           </a:xfrm>
@@ -4292,13 +4398,7 @@
       </p:pic>
       <p:sp>
         <p:nvSpPr>
-          <p:cNvPr id="29" name="TextBox 28">
-            <a:extLst>
-              <a:ext uri="{FF2B5EF4-FFF2-40B4-BE49-F238E27FC236}">
-                <a16:creationId xmlns:a16="http://schemas.microsoft.com/office/drawing/2014/main" id="{B5893605-57AC-DE0A-EABA-70CCE011C671}"/>
-              </a:ext>
-            </a:extLst>
-          </p:cNvPr>
+          <p:cNvPr id="29" name="TextBox 28"/>
           <p:cNvSpPr txBox="1"/>
           <p:nvPr/>
         </p:nvSpPr>
@@ -4427,7 +4527,6 @@
           <a:lstStyle/>
           <a:p>
             <a:pPr algn="ctr"/>
-            <a:endParaRPr/>
           </a:p>
         </p:txBody>
       </p:sp>
@@ -4471,7 +4570,6 @@
           <a:lstStyle/>
           <a:p>
             <a:pPr algn="ctr"/>
-            <a:endParaRPr/>
           </a:p>
         </p:txBody>
       </p:sp>
@@ -4515,7 +4613,6 @@
           <a:lstStyle/>
           <a:p>
             <a:pPr algn="ctr"/>
-            <a:endParaRPr/>
           </a:p>
         </p:txBody>
       </p:sp>
@@ -4568,6 +4665,12 @@
               </a:rPr>
               <a:t>08</a:t>
             </a:r>
+            <a:endParaRPr sz="2000" b="1">
+              <a:solidFill>
+                <a:srgbClr val="00336A"/>
+              </a:solidFill>
+              <a:latin typeface="Calibri"/>
+            </a:endParaRPr>
           </a:p>
         </p:txBody>
       </p:sp>
@@ -4602,6 +4705,12 @@
               </a:rPr>
               <a:t>Limitations, Future Work &amp; Conclusion</a:t>
             </a:r>
+            <a:endParaRPr sz="2000" b="1" dirty="0">
+              <a:solidFill>
+                <a:srgbClr val="FFFFFF"/>
+              </a:solidFill>
+              <a:latin typeface="Calibri"/>
+            </a:endParaRPr>
           </a:p>
           <a:p>
             <a:r>
@@ -4613,6 +4722,12 @@
               </a:rPr>
               <a:t>System Boundaries, Recommended Technical Roadmap, and Final Research Defense Conclusions</a:t>
             </a:r>
+            <a:endParaRPr sz="1200" i="1" dirty="0">
+              <a:solidFill>
+                <a:srgbClr val="BAE6FD"/>
+              </a:solidFill>
+              <a:latin typeface="Calibri"/>
+            </a:endParaRPr>
           </a:p>
         </p:txBody>
       </p:sp>
@@ -4656,7 +4771,6 @@
           <a:lstStyle/>
           <a:p>
             <a:pPr algn="ctr"/>
-            <a:endParaRPr/>
           </a:p>
         </p:txBody>
       </p:sp>
@@ -4691,6 +4805,12 @@
               </a:rPr>
               <a:t>QCampus Connect | Verified Academic Q&amp;A Forum &amp; Secure Consultation Platform | Case Study: UENR</a:t>
             </a:r>
+            <a:endParaRPr sz="850">
+              <a:solidFill>
+                <a:srgbClr val="475569"/>
+              </a:solidFill>
+              <a:latin typeface="Calibri"/>
+            </a:endParaRPr>
           </a:p>
         </p:txBody>
       </p:sp>
@@ -4726,6 +4846,12 @@
               </a:rPr>
               <a:t>Slide 08 / 08</a:t>
             </a:r>
+            <a:endParaRPr sz="850" b="1">
+              <a:solidFill>
+                <a:srgbClr val="00336A"/>
+              </a:solidFill>
+              <a:latin typeface="Calibri"/>
+            </a:endParaRPr>
           </a:p>
         </p:txBody>
       </p:sp>
@@ -4769,7 +4895,6 @@
           <a:lstStyle/>
           <a:p>
             <a:pPr algn="ctr"/>
-            <a:endParaRPr/>
           </a:p>
         </p:txBody>
       </p:sp>
@@ -4813,7 +4938,6 @@
           <a:lstStyle/>
           <a:p>
             <a:pPr algn="ctr"/>
-            <a:endParaRPr/>
           </a:p>
         </p:txBody>
       </p:sp>
@@ -4857,7 +4981,6 @@
           <a:lstStyle/>
           <a:p>
             <a:pPr algn="ctr"/>
-            <a:endParaRPr/>
           </a:p>
         </p:txBody>
       </p:sp>
@@ -4901,7 +5024,6 @@
           <a:lstStyle/>
           <a:p>
             <a:pPr algn="ctr"/>
-            <a:endParaRPr/>
           </a:p>
         </p:txBody>
       </p:sp>
@@ -4945,7 +5067,6 @@
           <a:lstStyle/>
           <a:p>
             <a:pPr algn="ctr"/>
-            <a:endParaRPr/>
           </a:p>
         </p:txBody>
       </p:sp>
@@ -5008,25 +5129,25 @@
               </a:rPr>
               <a:t> (PS001) | Dept. of Computer Science &amp; Informatics | UENR</a:t>
             </a:r>
+            <a:endParaRPr sz="1200" dirty="0">
+              <a:solidFill>
+                <a:srgbClr val="FFFFFF"/>
+              </a:solidFill>
+              <a:latin typeface="Calibri"/>
+            </a:endParaRPr>
           </a:p>
         </p:txBody>
       </p:sp>
       <p:pic>
         <p:nvPicPr>
-          <p:cNvPr id="23" name="Picture 22">
-            <a:extLst>
-              <a:ext uri="{FF2B5EF4-FFF2-40B4-BE49-F238E27FC236}">
-                <a16:creationId xmlns:a16="http://schemas.microsoft.com/office/drawing/2014/main" id="{2C3EAC98-5D38-C8A9-0942-81ED3BF2391C}"/>
-              </a:ext>
-            </a:extLst>
-          </p:cNvPr>
+          <p:cNvPr id="23" name="Picture 22"/>
           <p:cNvPicPr>
             <a:picLocks noChangeAspect="1"/>
           </p:cNvPicPr>
           <p:nvPr/>
         </p:nvPicPr>
         <p:blipFill>
-          <a:blip r:embed="rId2"/>
+          <a:blip r:embed="rId1"/>
           <a:stretch>
             <a:fillRect/>
           </a:stretch>
@@ -5046,13 +5167,7 @@
       </p:pic>
       <p:sp>
         <p:nvSpPr>
-          <p:cNvPr id="24" name="Rounded Rectangle 15">
-            <a:extLst>
-              <a:ext uri="{FF2B5EF4-FFF2-40B4-BE49-F238E27FC236}">
-                <a16:creationId xmlns:a16="http://schemas.microsoft.com/office/drawing/2014/main" id="{99B8712B-E94E-934D-A687-D56D83C264F8}"/>
-              </a:ext>
-            </a:extLst>
-          </p:cNvPr>
+          <p:cNvPr id="24" name="Rounded Rectangle 15"/>
           <p:cNvSpPr/>
           <p:nvPr/>
         </p:nvSpPr>
@@ -5104,8 +5219,8 @@
                 <a:solidFill>
                   <a:schemeClr val="tx2"/>
                 </a:solidFill>
-                <a:latin typeface="Arial" panose="020B0604020202020204" pitchFamily="34" charset="0"/>
-                <a:cs typeface="Arial" panose="020B0604020202020204" pitchFamily="34" charset="0"/>
+                <a:latin typeface="Arial" panose="02080604020202020204" pitchFamily="34" charset="0"/>
+                <a:cs typeface="Arial" panose="02080604020202020204" pitchFamily="34" charset="0"/>
               </a:rPr>
               <a:t>PROGRAM-SPECIFIC Q&amp;A AND UPDATES</a:t>
             </a:r>
@@ -5113,8 +5228,8 @@
               <a:solidFill>
                 <a:schemeClr val="tx2"/>
               </a:solidFill>
-              <a:latin typeface="Arial" panose="020B0604020202020204" pitchFamily="34" charset="0"/>
-              <a:cs typeface="Arial" panose="020B0604020202020204" pitchFamily="34" charset="0"/>
+              <a:latin typeface="Arial" panose="02080604020202020204" pitchFamily="34" charset="0"/>
+              <a:cs typeface="Arial" panose="02080604020202020204" pitchFamily="34" charset="0"/>
             </a:endParaRPr>
           </a:p>
           <a:p>
@@ -5126,18 +5241,17 @@
               </a:rPr>
               <a:t>The platform will be narrowed from a broad departmental structure to program-specific communities, allowing students and lecturers within the same program to access relevant academic questions, discussions, news, and updates without unnecessary information from other programs.</a:t>
             </a:r>
-          </a:p>
-        </p:txBody>
-      </p:sp>
-      <p:sp>
-        <p:nvSpPr>
-          <p:cNvPr id="36" name="Rounded Rectangle 15">
-            <a:extLst>
-              <a:ext uri="{FF2B5EF4-FFF2-40B4-BE49-F238E27FC236}">
-                <a16:creationId xmlns:a16="http://schemas.microsoft.com/office/drawing/2014/main" id="{73DB0844-5A6C-E386-D9C0-BAEF0BF9057F}"/>
-              </a:ext>
-            </a:extLst>
-          </p:cNvPr>
+            <a:endParaRPr lang="en-US" dirty="0">
+              <a:solidFill>
+                <a:schemeClr val="tx1"/>
+              </a:solidFill>
+            </a:endParaRPr>
+          </a:p>
+        </p:txBody>
+      </p:sp>
+      <p:sp>
+        <p:nvSpPr>
+          <p:cNvPr id="36" name="Rounded Rectangle 15"/>
           <p:cNvSpPr/>
           <p:nvPr/>
         </p:nvSpPr>
@@ -5181,11 +5295,18 @@
                 <a:solidFill>
                   <a:schemeClr val="tx2"/>
                 </a:solidFill>
-                <a:latin typeface="Arial" panose="020B0604020202020204" pitchFamily="34" charset="0"/>
-                <a:cs typeface="Arial" panose="020B0604020202020204" pitchFamily="34" charset="0"/>
+                <a:latin typeface="Arial" panose="02080604020202020204" pitchFamily="34" charset="0"/>
+                <a:cs typeface="Arial" panose="02080604020202020204" pitchFamily="34" charset="0"/>
               </a:rPr>
               <a:t>2. COURSE-SPECIFIC CHATROOMS</a:t>
             </a:r>
+            <a:endParaRPr lang="en-US" sz="1600" b="1" dirty="0">
+              <a:solidFill>
+                <a:schemeClr val="tx2"/>
+              </a:solidFill>
+              <a:latin typeface="Arial" panose="02080604020202020204" pitchFamily="34" charset="0"/>
+              <a:cs typeface="Arial" panose="02080604020202020204" pitchFamily="34" charset="0"/>
+            </a:endParaRPr>
           </a:p>
           <a:p>
             <a:r>
@@ -5196,18 +5317,17 @@
               </a:rPr>
               <a:t>Each course will have a dedicated chatroom where the lecturer and enrolled students can interact directly about course-related topics. This creates a focused space for asking questions, clarifying concepts, sharing resources, and discussing course activities.</a:t>
             </a:r>
-          </a:p>
-        </p:txBody>
-      </p:sp>
-      <p:sp>
-        <p:nvSpPr>
-          <p:cNvPr id="38" name="Rounded Rectangle 15">
-            <a:extLst>
-              <a:ext uri="{FF2B5EF4-FFF2-40B4-BE49-F238E27FC236}">
-                <a16:creationId xmlns:a16="http://schemas.microsoft.com/office/drawing/2014/main" id="{D3E09768-C9C3-5315-3240-6337F2F66063}"/>
-              </a:ext>
-            </a:extLst>
-          </p:cNvPr>
+            <a:endParaRPr lang="en-US" dirty="0">
+              <a:solidFill>
+                <a:schemeClr val="tx1"/>
+              </a:solidFill>
+            </a:endParaRPr>
+          </a:p>
+        </p:txBody>
+      </p:sp>
+      <p:sp>
+        <p:nvSpPr>
+          <p:cNvPr id="38" name="Rounded Rectangle 15"/>
           <p:cNvSpPr/>
           <p:nvPr/>
         </p:nvSpPr>
@@ -5251,11 +5371,18 @@
                 <a:solidFill>
                   <a:schemeClr val="tx2"/>
                 </a:solidFill>
-                <a:latin typeface="Arial" panose="020B0604020202020204" pitchFamily="34" charset="0"/>
-                <a:cs typeface="Arial" panose="020B0604020202020204" pitchFamily="34" charset="0"/>
+                <a:latin typeface="Arial" panose="02080604020202020204" pitchFamily="34" charset="0"/>
+                <a:cs typeface="Arial" panose="02080604020202020204" pitchFamily="34" charset="0"/>
               </a:rPr>
               <a:t>3. AUTOMATIC IDENTITY VERIFICATION</a:t>
             </a:r>
+            <a:endParaRPr lang="en-US" sz="1600" b="1" dirty="0">
+              <a:solidFill>
+                <a:schemeClr val="tx2"/>
+              </a:solidFill>
+              <a:latin typeface="Arial" panose="02080604020202020204" pitchFamily="34" charset="0"/>
+              <a:cs typeface="Arial" panose="02080604020202020204" pitchFamily="34" charset="0"/>
+            </a:endParaRPr>
           </a:p>
           <a:p>
             <a:r>
@@ -5282,18 +5409,17 @@
               </a:rPr>
               <a:t> with authorized university records, such as student identity details, name, and department/program. The goal is to automatically verify users and complete the verification process within seven days or less.</a:t>
             </a:r>
-          </a:p>
-        </p:txBody>
-      </p:sp>
-      <p:sp>
-        <p:nvSpPr>
-          <p:cNvPr id="40" name="Rounded Rectangle 15">
-            <a:extLst>
-              <a:ext uri="{FF2B5EF4-FFF2-40B4-BE49-F238E27FC236}">
-                <a16:creationId xmlns:a16="http://schemas.microsoft.com/office/drawing/2014/main" id="{2A3C6888-52F9-60BC-0E38-041D9FAAC91A}"/>
-              </a:ext>
-            </a:extLst>
-          </p:cNvPr>
+            <a:endParaRPr lang="en-US" dirty="0">
+              <a:solidFill>
+                <a:schemeClr val="tx1"/>
+              </a:solidFill>
+            </a:endParaRPr>
+          </a:p>
+        </p:txBody>
+      </p:sp>
+      <p:sp>
+        <p:nvSpPr>
+          <p:cNvPr id="40" name="Rounded Rectangle 15"/>
           <p:cNvSpPr/>
           <p:nvPr/>
         </p:nvSpPr>
@@ -5337,11 +5463,18 @@
                 <a:solidFill>
                   <a:schemeClr val="tx2"/>
                 </a:solidFill>
-                <a:latin typeface="Arial" panose="020B0604020202020204" pitchFamily="34" charset="0"/>
-                <a:cs typeface="Arial" panose="020B0604020202020204" pitchFamily="34" charset="0"/>
+                <a:latin typeface="Arial" panose="02080604020202020204" pitchFamily="34" charset="0"/>
+                <a:cs typeface="Arial" panose="02080604020202020204" pitchFamily="34" charset="0"/>
               </a:rPr>
               <a:t>4. DEPARTMENTAL NEWS &amp; NOTICE BOARD</a:t>
             </a:r>
+            <a:endParaRPr lang="en-US" sz="1600" b="1" dirty="0">
+              <a:solidFill>
+                <a:schemeClr val="tx2"/>
+              </a:solidFill>
+              <a:latin typeface="Arial" panose="02080604020202020204" pitchFamily="34" charset="0"/>
+              <a:cs typeface="Arial" panose="02080604020202020204" pitchFamily="34" charset="0"/>
+            </a:endParaRPr>
           </a:p>
           <a:p>
             <a:r>
@@ -5352,6 +5485,11 @@
               </a:rPr>
               <a:t>A dedicated departmental news and notice section will allow lecturers to publish announcements, updates, images, and files. Students and lecturers within the department can search posts by title, hashtags, department, or recent updates, while also commenting and interacting with published notices.</a:t>
             </a:r>
+            <a:endParaRPr lang="en-US" dirty="0">
+              <a:solidFill>
+                <a:schemeClr val="tx1"/>
+              </a:solidFill>
+            </a:endParaRPr>
           </a:p>
         </p:txBody>
       </p:sp>
@@ -5420,7 +5558,6 @@
           <a:lstStyle/>
           <a:p>
             <a:pPr algn="ctr"/>
-            <a:endParaRPr/>
           </a:p>
         </p:txBody>
       </p:sp>
@@ -5464,7 +5601,6 @@
           <a:lstStyle/>
           <a:p>
             <a:pPr algn="ctr"/>
-            <a:endParaRPr/>
           </a:p>
         </p:txBody>
       </p:sp>
@@ -5508,7 +5644,6 @@
           <a:lstStyle/>
           <a:p>
             <a:pPr algn="ctr"/>
-            <a:endParaRPr/>
           </a:p>
         </p:txBody>
       </p:sp>
@@ -5561,6 +5696,12 @@
               </a:rPr>
               <a:t>08</a:t>
             </a:r>
+            <a:endParaRPr sz="2000" b="1">
+              <a:solidFill>
+                <a:srgbClr val="00336A"/>
+              </a:solidFill>
+              <a:latin typeface="Calibri"/>
+            </a:endParaRPr>
           </a:p>
         </p:txBody>
       </p:sp>
@@ -5595,6 +5736,12 @@
               </a:rPr>
               <a:t>Limitations, Future Work &amp; Conclusion</a:t>
             </a:r>
+            <a:endParaRPr sz="2000" b="1" dirty="0">
+              <a:solidFill>
+                <a:srgbClr val="FFFFFF"/>
+              </a:solidFill>
+              <a:latin typeface="Calibri"/>
+            </a:endParaRPr>
           </a:p>
           <a:p>
             <a:r>
@@ -5606,6 +5753,12 @@
               </a:rPr>
               <a:t>System Boundaries, Recommended Technical Roadmap, and Final Research Defense Conclusions</a:t>
             </a:r>
+            <a:endParaRPr sz="1200" i="1" dirty="0">
+              <a:solidFill>
+                <a:srgbClr val="BAE6FD"/>
+              </a:solidFill>
+              <a:latin typeface="Calibri"/>
+            </a:endParaRPr>
           </a:p>
         </p:txBody>
       </p:sp>
@@ -5649,7 +5802,6 @@
           <a:lstStyle/>
           <a:p>
             <a:pPr algn="ctr"/>
-            <a:endParaRPr/>
           </a:p>
         </p:txBody>
       </p:sp>
@@ -5684,6 +5836,12 @@
               </a:rPr>
               <a:t>QCampus Connect | Verified Academic Q&amp;A Forum &amp; Secure Consultation Platform | Case Study: UENR</a:t>
             </a:r>
+            <a:endParaRPr sz="850">
+              <a:solidFill>
+                <a:srgbClr val="475569"/>
+              </a:solidFill>
+              <a:latin typeface="Calibri"/>
+            </a:endParaRPr>
           </a:p>
         </p:txBody>
       </p:sp>
@@ -5719,6 +5877,12 @@
               </a:rPr>
               <a:t>Slide 08 / 08</a:t>
             </a:r>
+            <a:endParaRPr sz="850" b="1">
+              <a:solidFill>
+                <a:srgbClr val="00336A"/>
+              </a:solidFill>
+              <a:latin typeface="Calibri"/>
+            </a:endParaRPr>
           </a:p>
         </p:txBody>
       </p:sp>
@@ -5764,7 +5928,6 @@
           <a:lstStyle/>
           <a:p>
             <a:pPr algn="ctr"/>
-            <a:endParaRPr/>
           </a:p>
         </p:txBody>
       </p:sp>
@@ -5808,7 +5971,6 @@
           <a:lstStyle/>
           <a:p>
             <a:pPr algn="ctr"/>
-            <a:endParaRPr/>
           </a:p>
         </p:txBody>
       </p:sp>
@@ -5852,6 +6014,12 @@
               </a:rPr>
               <a:t>System Constraints</a:t>
             </a:r>
+            <a:endParaRPr sz="2000" b="1" dirty="0">
+              <a:solidFill>
+                <a:srgbClr val="00336A"/>
+              </a:solidFill>
+              <a:latin typeface="Calibri"/>
+            </a:endParaRPr>
           </a:p>
           <a:p>
             <a:r>
@@ -5863,6 +6031,12 @@
               </a:rPr>
               <a:t>Current Boundaries</a:t>
             </a:r>
+            <a:endParaRPr sz="2000" b="1" dirty="0">
+              <a:solidFill>
+                <a:srgbClr val="F59E0B"/>
+              </a:solidFill>
+              <a:latin typeface="Calibri"/>
+            </a:endParaRPr>
           </a:p>
           <a:p>
             <a:pPr>
@@ -5900,6 +6074,12 @@
 • Standalone Authentication: Independent user directory; lacks university SAML/SSO link.
 • Web-Only Client: Desktop optimized; lacks native mobile application.</a:t>
             </a:r>
+            <a:endParaRPr sz="2000" dirty="0">
+              <a:solidFill>
+                <a:srgbClr val="1E293B"/>
+              </a:solidFill>
+              <a:latin typeface="Calibri"/>
+            </a:endParaRPr>
           </a:p>
         </p:txBody>
       </p:sp>
@@ -5945,7 +6125,6 @@
           <a:lstStyle/>
           <a:p>
             <a:pPr algn="ctr"/>
-            <a:endParaRPr/>
           </a:p>
         </p:txBody>
       </p:sp>
@@ -5989,7 +6168,6 @@
           <a:lstStyle/>
           <a:p>
             <a:pPr algn="ctr"/>
-            <a:endParaRPr/>
           </a:p>
         </p:txBody>
       </p:sp>
@@ -6033,6 +6211,12 @@
               </a:rPr>
               <a:t>Key Research Conclusions</a:t>
             </a:r>
+            <a:endParaRPr sz="2400" b="1" dirty="0">
+              <a:solidFill>
+                <a:srgbClr val="00336A"/>
+              </a:solidFill>
+              <a:latin typeface="Calibri"/>
+            </a:endParaRPr>
           </a:p>
           <a:p>
             <a:r>
@@ -6044,6 +6228,12 @@
               </a:rPr>
               <a:t>Defense Summary</a:t>
             </a:r>
+            <a:endParaRPr sz="2000" b="1" dirty="0">
+              <a:solidFill>
+                <a:srgbClr val="10B981"/>
+              </a:solidFill>
+              <a:latin typeface="Calibri"/>
+            </a:endParaRPr>
           </a:p>
           <a:p>
             <a:pPr>
@@ -6063,6 +6253,12 @@
 • Submission Disputes Solved: SHA-256 block timestamps replace easily falsified screenshots.
 • Production-Ready Blueprint: 0-error build ready for departmental adoption.</a:t>
             </a:r>
+            <a:endParaRPr sz="2000" dirty="0">
+              <a:solidFill>
+                <a:srgbClr val="1E293B"/>
+              </a:solidFill>
+              <a:latin typeface="Calibri"/>
+            </a:endParaRPr>
           </a:p>
         </p:txBody>
       </p:sp>
@@ -6106,7 +6302,6 @@
           <a:lstStyle/>
           <a:p>
             <a:pPr algn="ctr"/>
-            <a:endParaRPr/>
           </a:p>
         </p:txBody>
       </p:sp>
@@ -6150,7 +6345,6 @@
           <a:lstStyle/>
           <a:p>
             <a:pPr algn="ctr"/>
-            <a:endParaRPr/>
           </a:p>
         </p:txBody>
       </p:sp>
@@ -6213,25 +6407,25 @@
               </a:rPr>
               <a:t> (PS001) | Dept. of Computer Science &amp; Informatics | UENR</a:t>
             </a:r>
+            <a:endParaRPr sz="1200" dirty="0">
+              <a:solidFill>
+                <a:srgbClr val="FFFFFF"/>
+              </a:solidFill>
+              <a:latin typeface="Calibri"/>
+            </a:endParaRPr>
           </a:p>
         </p:txBody>
       </p:sp>
       <p:pic>
         <p:nvPicPr>
-          <p:cNvPr id="23" name="Picture 22">
-            <a:extLst>
-              <a:ext uri="{FF2B5EF4-FFF2-40B4-BE49-F238E27FC236}">
-                <a16:creationId xmlns:a16="http://schemas.microsoft.com/office/drawing/2014/main" id="{2C3EAC98-5D38-C8A9-0942-81ED3BF2391C}"/>
-              </a:ext>
-            </a:extLst>
-          </p:cNvPr>
+          <p:cNvPr id="23" name="Picture 22"/>
           <p:cNvPicPr>
             <a:picLocks noChangeAspect="1"/>
           </p:cNvPicPr>
           <p:nvPr/>
         </p:nvPicPr>
         <p:blipFill>
-          <a:blip r:embed="rId2"/>
+          <a:blip r:embed="rId1"/>
           <a:stretch>
             <a:fillRect/>
           </a:stretch>
@@ -6455,6 +6649,12 @@
               </a:rPr>
               <a:t>TOC</a:t>
             </a:r>
+            <a:endParaRPr sz="3600" b="1">
+              <a:solidFill>
+                <a:srgbClr val="00336A"/>
+              </a:solidFill>
+              <a:latin typeface="Calibri"/>
+            </a:endParaRPr>
           </a:p>
         </p:txBody>
       </p:sp>
@@ -6489,6 +6689,12 @@
               </a:rPr>
               <a:t>Table of Contents</a:t>
             </a:r>
+            <a:endParaRPr sz="3600" b="1">
+              <a:solidFill>
+                <a:srgbClr val="FFFFFF"/>
+              </a:solidFill>
+              <a:latin typeface="Calibri"/>
+            </a:endParaRPr>
           </a:p>
           <a:p>
             <a:r>
@@ -6500,6 +6706,12 @@
               </a:rPr>
               <a:t>Executive Overview of Presentation Structure (8 Core Topics)</a:t>
             </a:r>
+            <a:endParaRPr i="1">
+              <a:solidFill>
+                <a:srgbClr val="BAE6FD"/>
+              </a:solidFill>
+              <a:latin typeface="Calibri"/>
+            </a:endParaRPr>
           </a:p>
         </p:txBody>
       </p:sp>
@@ -6578,6 +6790,12 @@
               </a:rPr>
               <a:t>QCampus Connect | Verified Academic Q&amp;A Forum &amp; Secure Consultation Platform | Case Study: UENR</a:t>
             </a:r>
+            <a:endParaRPr sz="1100">
+              <a:solidFill>
+                <a:srgbClr val="475569"/>
+              </a:solidFill>
+              <a:latin typeface="Calibri"/>
+            </a:endParaRPr>
           </a:p>
         </p:txBody>
       </p:sp>
@@ -6613,6 +6831,12 @@
               </a:rPr>
               <a:t>Slide TOC / 08</a:t>
             </a:r>
+            <a:endParaRPr sz="1100" b="1">
+              <a:solidFill>
+                <a:srgbClr val="00336A"/>
+              </a:solidFill>
+              <a:latin typeface="Calibri"/>
+            </a:endParaRPr>
           </a:p>
         </p:txBody>
       </p:sp>
@@ -6711,6 +6935,12 @@
               </a:rPr>
               <a:t>01</a:t>
             </a:r>
+            <a:endParaRPr sz="2800" b="1">
+              <a:solidFill>
+                <a:srgbClr val="00336A"/>
+              </a:solidFill>
+              <a:latin typeface="Calibri"/>
+            </a:endParaRPr>
           </a:p>
         </p:txBody>
       </p:sp>
@@ -6745,6 +6975,12 @@
               </a:rPr>
               <a:t>Background &amp; Academic Reality in Higher Ed</a:t>
             </a:r>
+            <a:endParaRPr sz="1600" b="1" dirty="0">
+              <a:solidFill>
+                <a:srgbClr val="00336A"/>
+              </a:solidFill>
+              <a:latin typeface="Calibri"/>
+            </a:endParaRPr>
           </a:p>
           <a:p>
             <a:pPr>
@@ -6761,6 +6997,12 @@
               </a:rPr>
               <a:t>The missing academic commons, campus bottlenecks &amp; informal channel failure</a:t>
             </a:r>
+            <a:endParaRPr sz="1200" dirty="0">
+              <a:solidFill>
+                <a:srgbClr val="475569"/>
+              </a:solidFill>
+              <a:latin typeface="Calibri"/>
+            </a:endParaRPr>
           </a:p>
         </p:txBody>
       </p:sp>
@@ -6859,6 +7101,12 @@
               </a:rPr>
               <a:t>02</a:t>
             </a:r>
+            <a:endParaRPr sz="2800" b="1">
+              <a:solidFill>
+                <a:srgbClr val="00336A"/>
+              </a:solidFill>
+              <a:latin typeface="Calibri"/>
+            </a:endParaRPr>
           </a:p>
         </p:txBody>
       </p:sp>
@@ -6893,6 +7141,12 @@
               </a:rPr>
               <a:t>Problem Statement &amp; Communication Gaps</a:t>
             </a:r>
+            <a:endParaRPr sz="1600" b="1" dirty="0">
+              <a:solidFill>
+                <a:srgbClr val="00336A"/>
+              </a:solidFill>
+              <a:latin typeface="Calibri"/>
+            </a:endParaRPr>
           </a:p>
           <a:p>
             <a:pPr>
@@ -6909,6 +7163,12 @@
               </a:rPr>
               <a:t>Academic isolation, unverified advice, redundant faculty workload &amp; mutable logs</a:t>
             </a:r>
+            <a:endParaRPr sz="1200" dirty="0">
+              <a:solidFill>
+                <a:srgbClr val="475569"/>
+              </a:solidFill>
+              <a:latin typeface="Calibri"/>
+            </a:endParaRPr>
           </a:p>
         </p:txBody>
       </p:sp>
@@ -7007,6 +7267,12 @@
               </a:rPr>
               <a:t>03</a:t>
             </a:r>
+            <a:endParaRPr sz="2800" b="1">
+              <a:solidFill>
+                <a:srgbClr val="00336A"/>
+              </a:solidFill>
+              <a:latin typeface="Calibri"/>
+            </a:endParaRPr>
           </a:p>
         </p:txBody>
       </p:sp>
@@ -7041,6 +7307,12 @@
               </a:rPr>
               <a:t>Aim &amp; Specific Research Objectives</a:t>
             </a:r>
+            <a:endParaRPr sz="1600" b="1" dirty="0">
+              <a:solidFill>
+                <a:srgbClr val="00336A"/>
+              </a:solidFill>
+              <a:latin typeface="Calibri"/>
+            </a:endParaRPr>
           </a:p>
           <a:p>
             <a:pPr>
@@ -7057,6 +7329,12 @@
               </a:rPr>
               <a:t>Institutional Q&amp;A forum, authority badging, encrypted DMs &amp; Besu audit trail</a:t>
             </a:r>
+            <a:endParaRPr sz="1200" dirty="0">
+              <a:solidFill>
+                <a:srgbClr val="475569"/>
+              </a:solidFill>
+              <a:latin typeface="Calibri"/>
+            </a:endParaRPr>
           </a:p>
         </p:txBody>
       </p:sp>
@@ -7155,6 +7433,12 @@
               </a:rPr>
               <a:t>04</a:t>
             </a:r>
+            <a:endParaRPr sz="2800" b="1">
+              <a:solidFill>
+                <a:srgbClr val="00336A"/>
+              </a:solidFill>
+              <a:latin typeface="Calibri"/>
+            </a:endParaRPr>
           </a:p>
         </p:txBody>
       </p:sp>
@@ -7189,6 +7473,12 @@
               </a:rPr>
               <a:t>Related Work &amp; Platform Comparison</a:t>
             </a:r>
+            <a:endParaRPr sz="1600" b="1" dirty="0">
+              <a:solidFill>
+                <a:srgbClr val="00336A"/>
+              </a:solidFill>
+              <a:latin typeface="Calibri"/>
+            </a:endParaRPr>
           </a:p>
           <a:p>
             <a:pPr>
@@ -7223,6 +7513,12 @@
               </a:rPr>
               <a:t> Connect</a:t>
             </a:r>
+            <a:endParaRPr sz="1200" dirty="0">
+              <a:solidFill>
+                <a:srgbClr val="475569"/>
+              </a:solidFill>
+              <a:latin typeface="Calibri"/>
+            </a:endParaRPr>
           </a:p>
         </p:txBody>
       </p:sp>
@@ -7321,6 +7617,12 @@
               </a:rPr>
               <a:t>05</a:t>
             </a:r>
+            <a:endParaRPr sz="2800" b="1">
+              <a:solidFill>
+                <a:srgbClr val="00336A"/>
+              </a:solidFill>
+              <a:latin typeface="Calibri"/>
+            </a:endParaRPr>
           </a:p>
         </p:txBody>
       </p:sp>
@@ -7355,6 +7657,12 @@
               </a:rPr>
               <a:t>Methodology &amp; System Architecture</a:t>
             </a:r>
+            <a:endParaRPr sz="1600" b="1" dirty="0">
+              <a:solidFill>
+                <a:srgbClr val="00336A"/>
+              </a:solidFill>
+              <a:latin typeface="Calibri"/>
+            </a:endParaRPr>
           </a:p>
           <a:p>
             <a:pPr>
@@ -7371,6 +7679,12 @@
               </a:rPr>
               <a:t>3-tier hybrid enterprise stack: React 19 SPA, Convex real-time &amp; Hyperledger Besu</a:t>
             </a:r>
+            <a:endParaRPr sz="1200" dirty="0">
+              <a:solidFill>
+                <a:srgbClr val="475569"/>
+              </a:solidFill>
+              <a:latin typeface="Calibri"/>
+            </a:endParaRPr>
           </a:p>
         </p:txBody>
       </p:sp>
@@ -7469,6 +7783,12 @@
               </a:rPr>
               <a:t>06</a:t>
             </a:r>
+            <a:endParaRPr sz="2800" b="1">
+              <a:solidFill>
+                <a:srgbClr val="00336A"/>
+              </a:solidFill>
+              <a:latin typeface="Calibri"/>
+            </a:endParaRPr>
           </a:p>
         </p:txBody>
       </p:sp>
@@ -7503,6 +7823,12 @@
               </a:rPr>
               <a:t>Academic Q&amp;A &amp; Identity Audit Workflow</a:t>
             </a:r>
+            <a:endParaRPr sz="1600" b="1" dirty="0">
+              <a:solidFill>
+                <a:srgbClr val="00336A"/>
+              </a:solidFill>
+              <a:latin typeface="Calibri"/>
+            </a:endParaRPr>
           </a:p>
           <a:p>
             <a:pPr>
@@ -7519,6 +7845,12 @@
               </a:rPr>
               <a:t>6-step end-to-end verification lifecycle: classification, badging, DM &amp; ledger audit</a:t>
             </a:r>
+            <a:endParaRPr sz="1200" dirty="0">
+              <a:solidFill>
+                <a:srgbClr val="475569"/>
+              </a:solidFill>
+              <a:latin typeface="Calibri"/>
+            </a:endParaRPr>
           </a:p>
         </p:txBody>
       </p:sp>
@@ -7617,6 +7949,12 @@
               </a:rPr>
               <a:t>07</a:t>
             </a:r>
+            <a:endParaRPr sz="2800" b="1">
+              <a:solidFill>
+                <a:srgbClr val="00336A"/>
+              </a:solidFill>
+              <a:latin typeface="Calibri"/>
+            </a:endParaRPr>
           </a:p>
         </p:txBody>
       </p:sp>
@@ -7651,6 +7989,12 @@
               </a:rPr>
               <a:t>Empirical Results &amp; Live System Demo</a:t>
             </a:r>
+            <a:endParaRPr sz="1600" b="1" dirty="0">
+              <a:solidFill>
+                <a:srgbClr val="00336A"/>
+              </a:solidFill>
+              <a:latin typeface="Calibri"/>
+            </a:endParaRPr>
           </a:p>
           <a:p>
             <a:pPr>
@@ -7667,6 +8011,12 @@
               </a:rPr>
               <a:t>100% PASS verification suite, sub-50ms latency &amp; panel-ready live feature demo</a:t>
             </a:r>
+            <a:endParaRPr sz="1200" dirty="0">
+              <a:solidFill>
+                <a:srgbClr val="475569"/>
+              </a:solidFill>
+              <a:latin typeface="Calibri"/>
+            </a:endParaRPr>
           </a:p>
         </p:txBody>
       </p:sp>
@@ -7765,6 +8115,12 @@
               </a:rPr>
               <a:t>08</a:t>
             </a:r>
+            <a:endParaRPr sz="2800" b="1">
+              <a:solidFill>
+                <a:srgbClr val="00336A"/>
+              </a:solidFill>
+              <a:latin typeface="Calibri"/>
+            </a:endParaRPr>
           </a:p>
         </p:txBody>
       </p:sp>
@@ -7799,6 +8155,12 @@
               </a:rPr>
               <a:t>Limitations, Future Work &amp; Conclusion</a:t>
             </a:r>
+            <a:endParaRPr sz="1600" b="1" dirty="0">
+              <a:solidFill>
+                <a:srgbClr val="00336A"/>
+              </a:solidFill>
+              <a:latin typeface="Calibri"/>
+            </a:endParaRPr>
           </a:p>
           <a:p>
             <a:pPr>
@@ -7815,6 +8177,12 @@
               </a:rPr>
               <a:t>System boundaries, multi-node consortium roadmap &amp; final project conclusions</a:t>
             </a:r>
+            <a:endParaRPr sz="1200" dirty="0">
+              <a:solidFill>
+                <a:srgbClr val="475569"/>
+              </a:solidFill>
+              <a:latin typeface="Calibri"/>
+            </a:endParaRPr>
           </a:p>
         </p:txBody>
       </p:sp>
@@ -7947,25 +8315,25 @@
               </a:rPr>
               <a:t>Structured 10-slide defense aligned with the Department of Computer Science &amp; Informatics guidelines.</a:t>
             </a:r>
+            <a:endParaRPr sz="1750" dirty="0">
+              <a:solidFill>
+                <a:srgbClr val="FFFFFF"/>
+              </a:solidFill>
+              <a:latin typeface="Calibri"/>
+            </a:endParaRPr>
           </a:p>
         </p:txBody>
       </p:sp>
       <p:pic>
         <p:nvPicPr>
-          <p:cNvPr id="40" name="Picture 39">
-            <a:extLst>
-              <a:ext uri="{FF2B5EF4-FFF2-40B4-BE49-F238E27FC236}">
-                <a16:creationId xmlns:a16="http://schemas.microsoft.com/office/drawing/2014/main" id="{CE983A81-EE18-71BD-3A7C-7FD414581DCC}"/>
-              </a:ext>
-            </a:extLst>
-          </p:cNvPr>
+          <p:cNvPr id="40" name="Picture 39"/>
           <p:cNvPicPr>
             <a:picLocks noChangeAspect="1"/>
           </p:cNvPicPr>
           <p:nvPr/>
         </p:nvPicPr>
         <p:blipFill>
-          <a:blip r:embed="rId2"/>
+          <a:blip r:embed="rId1"/>
           <a:stretch>
             <a:fillRect/>
           </a:stretch>
@@ -8189,6 +8557,12 @@
               </a:rPr>
               <a:t>01</a:t>
             </a:r>
+            <a:endParaRPr sz="2400" b="1">
+              <a:solidFill>
+                <a:srgbClr val="00336A"/>
+              </a:solidFill>
+              <a:latin typeface="Calibri"/>
+            </a:endParaRPr>
           </a:p>
         </p:txBody>
       </p:sp>
@@ -8223,6 +8597,12 @@
               </a:rPr>
               <a:t>Background &amp; Academic Reality in Higher Education</a:t>
             </a:r>
+            <a:endParaRPr sz="2400" b="1">
+              <a:solidFill>
+                <a:srgbClr val="FFFFFF"/>
+              </a:solidFill>
+              <a:latin typeface="Calibri"/>
+            </a:endParaRPr>
           </a:p>
           <a:p>
             <a:r>
@@ -8234,6 +8614,12 @@
               </a:rPr>
               <a:t>The Missing Academic Commons in Universities &amp; The Failure of Informal Channels (Case Study: UENR)</a:t>
             </a:r>
+            <a:endParaRPr sz="1200" i="1">
+              <a:solidFill>
+                <a:srgbClr val="BAE6FD"/>
+              </a:solidFill>
+              <a:latin typeface="Calibri"/>
+            </a:endParaRPr>
           </a:p>
         </p:txBody>
       </p:sp>
@@ -8312,6 +8698,12 @@
               </a:rPr>
               <a:t>QCampus Connect | Verified Academic Q&amp;A Forum &amp; Secure Consultation Platform | Case Study: UENR</a:t>
             </a:r>
+            <a:endParaRPr sz="900">
+              <a:solidFill>
+                <a:srgbClr val="475569"/>
+              </a:solidFill>
+              <a:latin typeface="Calibri"/>
+            </a:endParaRPr>
           </a:p>
         </p:txBody>
       </p:sp>
@@ -8347,6 +8739,12 @@
               </a:rPr>
               <a:t>Slide 01 / 08</a:t>
             </a:r>
+            <a:endParaRPr sz="900" b="1">
+              <a:solidFill>
+                <a:srgbClr val="00336A"/>
+              </a:solidFill>
+              <a:latin typeface="Calibri"/>
+            </a:endParaRPr>
           </a:p>
         </p:txBody>
       </p:sp>
@@ -8427,6 +8825,12 @@
               </a:rPr>
               <a:t>🏛️ The Missing Academic Commons in Higher Education</a:t>
             </a:r>
+            <a:endParaRPr sz="1600" b="1" dirty="0">
+              <a:solidFill>
+                <a:srgbClr val="00336A"/>
+              </a:solidFill>
+              <a:latin typeface="Calibri"/>
+            </a:endParaRPr>
           </a:p>
           <a:p>
             <a:pPr>
@@ -8452,6 +8856,12 @@
               </a:rPr>
               <a:t>Universities invest in grade portals and static LMS (lecture notes), but lack an open, interactive academic commons for student-faculty scholarly discussions.</a:t>
             </a:r>
+            <a:endParaRPr sz="1200" dirty="0">
+              <a:solidFill>
+                <a:srgbClr val="475569"/>
+              </a:solidFill>
+              <a:latin typeface="Calibri"/>
+            </a:endParaRPr>
           </a:p>
           <a:p>
             <a:pPr>
@@ -8477,6 +8887,12 @@
               </a:rPr>
               <a:t>To clarify coursework or project problems, students must physically hunt lecturers across campus buildings, queue outside offices, or make unscheduled phone calls.</a:t>
             </a:r>
+            <a:endParaRPr sz="1200" dirty="0">
+              <a:solidFill>
+                <a:srgbClr val="475569"/>
+              </a:solidFill>
+              <a:latin typeface="Calibri"/>
+            </a:endParaRPr>
           </a:p>
           <a:p>
             <a:pPr>
@@ -8511,6 +8927,12 @@
               </a:rPr>
               <a:t>.</a:t>
             </a:r>
+            <a:endParaRPr sz="1050" dirty="0">
+              <a:solidFill>
+                <a:srgbClr val="475569"/>
+              </a:solidFill>
+              <a:latin typeface="Calibri"/>
+            </a:endParaRPr>
           </a:p>
         </p:txBody>
       </p:sp>
@@ -8591,6 +9013,12 @@
               </a:rPr>
               <a:t>⚠️ Why Informal Channels (WhatsApp / Telegram) Fail</a:t>
             </a:r>
+            <a:endParaRPr sz="1600" b="1" dirty="0">
+              <a:solidFill>
+                <a:srgbClr val="B91C1C"/>
+              </a:solidFill>
+              <a:latin typeface="Calibri"/>
+            </a:endParaRPr>
           </a:p>
           <a:p>
             <a:pPr>
@@ -8616,6 +9044,12 @@
               </a:rPr>
               <a:t>Informal groups mix casual banter, memes, and administrative noise; serious academic inquiries and technical findings are quickly buried.</a:t>
             </a:r>
+            <a:endParaRPr sz="1200" dirty="0">
+              <a:solidFill>
+                <a:srgbClr val="475569"/>
+              </a:solidFill>
+              <a:latin typeface="Calibri"/>
+            </a:endParaRPr>
           </a:p>
           <a:p>
             <a:pPr>
@@ -8641,6 +9075,12 @@
               </a:rPr>
               <a:t>Lecturers repeatedly answer the exact same questions for different students in private DMs with no searchable institutional knowledge archive.</a:t>
             </a:r>
+            <a:endParaRPr sz="1200" dirty="0">
+              <a:solidFill>
+                <a:srgbClr val="475569"/>
+              </a:solidFill>
+              <a:latin typeface="Calibri"/>
+            </a:endParaRPr>
           </a:p>
           <a:p>
             <a:pPr>
@@ -8684,6 +9124,12 @@
               </a:rPr>
               <a:t>A centralized university Q&amp;A forum where discussions are public, searchable, and verified, with 1-on-1 messaging reserved only as a follow-up consultation tool.</a:t>
             </a:r>
+            <a:endParaRPr sz="1200" dirty="0">
+              <a:solidFill>
+                <a:srgbClr val="475569"/>
+              </a:solidFill>
+              <a:latin typeface="Calibri"/>
+            </a:endParaRPr>
           </a:p>
         </p:txBody>
       </p:sp>
@@ -8783,6 +9229,12 @@
               </a:rPr>
               <a:t>📸  WORKFLOW COMPARISON &amp; PROBLEM SCENARIO</a:t>
             </a:r>
+            <a:endParaRPr sz="1400" b="1" dirty="0">
+              <a:solidFill>
+                <a:srgbClr val="FFFFFF"/>
+              </a:solidFill>
+              <a:latin typeface="Calibri"/>
+            </a:endParaRPr>
           </a:p>
         </p:txBody>
       </p:sp>
@@ -8836,6 +9288,12 @@
               </a:rPr>
               <a:t> Connect Digital Commons</a:t>
             </a:r>
+            <a:endParaRPr sz="1600" b="1" i="1" dirty="0">
+              <a:solidFill>
+                <a:srgbClr val="00509E"/>
+              </a:solidFill>
+              <a:latin typeface="Calibri"/>
+            </a:endParaRPr>
           </a:p>
           <a:p>
             <a:pPr>
@@ -8852,6 +9310,12 @@
               </a:rPr>
               <a:t>• Left Side: Traditional Breakdown (Office queues, unscheduled phone calls, WhatsApp noise, duplicate DMs).</a:t>
             </a:r>
+            <a:endParaRPr sz="1400" dirty="0">
+              <a:solidFill>
+                <a:srgbClr val="1E293B"/>
+              </a:solidFill>
+              <a:latin typeface="Calibri"/>
+            </a:endParaRPr>
           </a:p>
           <a:p>
             <a:pPr>
@@ -8886,6 +9350,12 @@
               </a:rPr>
               <a:t> Connect Model (Public Forum Question -&gt; Verified Faculty Answer -&gt; Searchable Knowledge -&gt; Optional 1-on-1 Consultation).</a:t>
             </a:r>
+            <a:endParaRPr sz="1400" dirty="0">
+              <a:solidFill>
+                <a:srgbClr val="1E293B"/>
+              </a:solidFill>
+              <a:latin typeface="Calibri"/>
+            </a:endParaRPr>
           </a:p>
           <a:p>
             <a:pPr>
@@ -8902,6 +9372,12 @@
               </a:rPr>
               <a:t>• Demonstrates how public Q&amp;A solves the 1-to-many knowledge distribution barrier.</a:t>
             </a:r>
+            <a:endParaRPr sz="1400" dirty="0">
+              <a:solidFill>
+                <a:srgbClr val="1E293B"/>
+              </a:solidFill>
+              <a:latin typeface="Calibri"/>
+            </a:endParaRPr>
           </a:p>
           <a:p>
             <a:pPr>
@@ -8918,6 +9394,12 @@
               </a:rPr>
               <a:t>• Shows the seamless transition to client-encrypted direct messaging for deep private consultations.</a:t>
             </a:r>
+            <a:endParaRPr sz="1400" dirty="0">
+              <a:solidFill>
+                <a:srgbClr val="1E293B"/>
+              </a:solidFill>
+              <a:latin typeface="Calibri"/>
+            </a:endParaRPr>
           </a:p>
           <a:p>
             <a:pPr>
@@ -8934,6 +9416,12 @@
               </a:rPr>
               <a:t>• Eliminates late-night WhatsApp submission disputes with cryptographic timestamp proof.</a:t>
             </a:r>
+            <a:endParaRPr sz="1400" dirty="0">
+              <a:solidFill>
+                <a:srgbClr val="1E293B"/>
+              </a:solidFill>
+              <a:latin typeface="Calibri"/>
+            </a:endParaRPr>
           </a:p>
         </p:txBody>
       </p:sp>
@@ -9066,25 +9554,25 @@
               </a:rPr>
               <a:t>Academic discussions must be open, centralized, and persistent so one lecturer explanation benefits the entire student cohort.</a:t>
             </a:r>
+            <a:endParaRPr sz="1200">
+              <a:solidFill>
+                <a:srgbClr val="FFFFFF"/>
+              </a:solidFill>
+              <a:latin typeface="Calibri"/>
+            </a:endParaRPr>
           </a:p>
         </p:txBody>
       </p:sp>
       <p:pic>
         <p:nvPicPr>
-          <p:cNvPr id="21" name="Picture 20">
-            <a:extLst>
-              <a:ext uri="{FF2B5EF4-FFF2-40B4-BE49-F238E27FC236}">
-                <a16:creationId xmlns:a16="http://schemas.microsoft.com/office/drawing/2014/main" id="{30EC0D5D-503F-F0F1-09AE-9A847E05C6D3}"/>
-              </a:ext>
-            </a:extLst>
-          </p:cNvPr>
+          <p:cNvPr id="21" name="Picture 20"/>
           <p:cNvPicPr>
             <a:picLocks noChangeAspect="1"/>
           </p:cNvPicPr>
           <p:nvPr/>
         </p:nvPicPr>
         <p:blipFill>
-          <a:blip r:embed="rId2"/>
+          <a:blip r:embed="rId1"/>
           <a:stretch>
             <a:fillRect/>
           </a:stretch>
@@ -9167,7 +9655,6 @@
           <a:lstStyle/>
           <a:p>
             <a:pPr algn="ctr"/>
-            <a:endParaRPr/>
           </a:p>
         </p:txBody>
       </p:sp>
@@ -9211,7 +9698,6 @@
           <a:lstStyle/>
           <a:p>
             <a:pPr algn="ctr"/>
-            <a:endParaRPr/>
           </a:p>
         </p:txBody>
       </p:sp>
@@ -9255,7 +9741,6 @@
           <a:lstStyle/>
           <a:p>
             <a:pPr algn="ctr"/>
-            <a:endParaRPr/>
           </a:p>
         </p:txBody>
       </p:sp>
@@ -9308,6 +9793,12 @@
               </a:rPr>
               <a:t>02</a:t>
             </a:r>
+            <a:endParaRPr sz="2000" b="1">
+              <a:solidFill>
+                <a:srgbClr val="00336A"/>
+              </a:solidFill>
+              <a:latin typeface="Calibri"/>
+            </a:endParaRPr>
           </a:p>
         </p:txBody>
       </p:sp>
@@ -9342,6 +9833,12 @@
               </a:rPr>
               <a:t>Problem Statement: Higher Education Communication Gap</a:t>
             </a:r>
+            <a:endParaRPr sz="2000" b="1" dirty="0">
+              <a:solidFill>
+                <a:srgbClr val="FFFFFF"/>
+              </a:solidFill>
+              <a:latin typeface="Calibri"/>
+            </a:endParaRPr>
           </a:p>
           <a:p>
             <a:r>
@@ -9353,6 +9850,12 @@
               </a:rPr>
               <a:t>Four Critical Institutional Bottlenecks in Campus Communication &amp; Student-Faculty Collaboration</a:t>
             </a:r>
+            <a:endParaRPr sz="1200" i="1" dirty="0">
+              <a:solidFill>
+                <a:srgbClr val="BAE6FD"/>
+              </a:solidFill>
+              <a:latin typeface="Calibri"/>
+            </a:endParaRPr>
           </a:p>
         </p:txBody>
       </p:sp>
@@ -9396,7 +9899,6 @@
           <a:lstStyle/>
           <a:p>
             <a:pPr algn="ctr"/>
-            <a:endParaRPr/>
           </a:p>
         </p:txBody>
       </p:sp>
@@ -9431,6 +9933,12 @@
               </a:rPr>
               <a:t>QCampus Connect | Verified Academic Q&amp;A Forum &amp; Secure Consultation Platform | Case Study: UENR</a:t>
             </a:r>
+            <a:endParaRPr sz="850">
+              <a:solidFill>
+                <a:srgbClr val="475569"/>
+              </a:solidFill>
+              <a:latin typeface="Calibri"/>
+            </a:endParaRPr>
           </a:p>
         </p:txBody>
       </p:sp>
@@ -9466,6 +9974,12 @@
               </a:rPr>
               <a:t>Slide 02 / 08</a:t>
             </a:r>
+            <a:endParaRPr sz="850" b="1">
+              <a:solidFill>
+                <a:srgbClr val="00336A"/>
+              </a:solidFill>
+              <a:latin typeface="Calibri"/>
+            </a:endParaRPr>
           </a:p>
         </p:txBody>
       </p:sp>
@@ -9511,7 +10025,6 @@
           <a:lstStyle/>
           <a:p>
             <a:pPr algn="ctr"/>
-            <a:endParaRPr/>
           </a:p>
         </p:txBody>
       </p:sp>
@@ -9555,7 +10068,6 @@
           <a:lstStyle/>
           <a:p>
             <a:pPr algn="ctr"/>
-            <a:endParaRPr/>
           </a:p>
         </p:txBody>
       </p:sp>
@@ -9590,6 +10102,12 @@
               </a:rPr>
               <a:t>Problem 1: Academic Isolation &amp; Inaccessibility</a:t>
             </a:r>
+            <a:endParaRPr sz="1400" b="1" dirty="0">
+              <a:solidFill>
+                <a:srgbClr val="EF4444"/>
+              </a:solidFill>
+              <a:latin typeface="Calibri"/>
+            </a:endParaRPr>
           </a:p>
           <a:p>
             <a:r>
@@ -9601,6 +10119,12 @@
               </a:rPr>
               <a:t>Office Queue Bottlenecks &amp; Physical Barriers</a:t>
             </a:r>
+            <a:endParaRPr sz="1200" b="1" dirty="0">
+              <a:solidFill>
+                <a:srgbClr val="1E293B"/>
+              </a:solidFill>
+              <a:latin typeface="Calibri"/>
+            </a:endParaRPr>
           </a:p>
           <a:p>
             <a:pPr>
@@ -9619,6 +10143,12 @@
 • Off-campus, commuting, distance, or introverted students receive zero guidance outside limited physical office hours.
 • Critical academic clarification is unavailable during revision and project deadlines.</a:t>
             </a:r>
+            <a:endParaRPr sz="1200" dirty="0">
+              <a:solidFill>
+                <a:srgbClr val="475569"/>
+              </a:solidFill>
+              <a:latin typeface="Calibri"/>
+            </a:endParaRPr>
           </a:p>
         </p:txBody>
       </p:sp>
@@ -9664,7 +10194,6 @@
           <a:lstStyle/>
           <a:p>
             <a:pPr algn="ctr"/>
-            <a:endParaRPr/>
           </a:p>
         </p:txBody>
       </p:sp>
@@ -9708,7 +10237,6 @@
           <a:lstStyle/>
           <a:p>
             <a:pPr algn="ctr"/>
-            <a:endParaRPr/>
           </a:p>
         </p:txBody>
       </p:sp>
@@ -9743,6 +10271,12 @@
               </a:rPr>
               <a:t>Problem 2: Unqualified Advice as Expert Authority</a:t>
             </a:r>
+            <a:endParaRPr sz="1400" b="1" dirty="0">
+              <a:solidFill>
+                <a:srgbClr val="F59E0B"/>
+              </a:solidFill>
+              <a:latin typeface="Calibri"/>
+            </a:endParaRPr>
           </a:p>
           <a:p>
             <a:r>
@@ -9754,6 +10288,12 @@
               </a:rPr>
               <a:t>Social Media Hearsay &amp; Rumor Propagation</a:t>
             </a:r>
+            <a:endParaRPr sz="1200" b="1" dirty="0">
+              <a:solidFill>
+                <a:srgbClr val="1E293B"/>
+              </a:solidFill>
+              <a:latin typeface="Calibri"/>
+            </a:endParaRPr>
           </a:p>
           <a:p>
             <a:pPr>
@@ -9772,6 +10312,12 @@
 • Unverified rumors regarding exam dates, grading criteria, and coursework solutions circulate unchecked.
 • No institutional badges exist to distinguish real professors from casual students.</a:t>
             </a:r>
+            <a:endParaRPr sz="1200" dirty="0">
+              <a:solidFill>
+                <a:srgbClr val="475569"/>
+              </a:solidFill>
+              <a:latin typeface="Calibri"/>
+            </a:endParaRPr>
           </a:p>
         </p:txBody>
       </p:sp>
@@ -9817,7 +10363,6 @@
           <a:lstStyle/>
           <a:p>
             <a:pPr algn="ctr"/>
-            <a:endParaRPr/>
           </a:p>
         </p:txBody>
       </p:sp>
@@ -9861,7 +10406,6 @@
           <a:lstStyle/>
           <a:p>
             <a:pPr algn="ctr"/>
-            <a:endParaRPr/>
           </a:p>
         </p:txBody>
       </p:sp>
@@ -9896,6 +10440,12 @@
               </a:rPr>
               <a:t>Problem 3: Redundant Repetition &amp; Faculty Burden</a:t>
             </a:r>
+            <a:endParaRPr sz="1400" b="1" dirty="0">
+              <a:solidFill>
+                <a:srgbClr val="3B82F6"/>
+              </a:solidFill>
+              <a:latin typeface="Calibri"/>
+            </a:endParaRPr>
           </a:p>
           <a:p>
             <a:r>
@@ -9907,6 +10457,12 @@
               </a:rPr>
               <a:t>Knowledge Trapped in 1-on-1 Silos</a:t>
             </a:r>
+            <a:endParaRPr sz="1200" b="1" dirty="0">
+              <a:solidFill>
+                <a:srgbClr val="1E293B"/>
+              </a:solidFill>
+              <a:latin typeface="Calibri"/>
+            </a:endParaRPr>
           </a:p>
           <a:p>
             <a:pPr>
@@ -9925,6 +10481,12 @@
 • Explanations given in 1-on-1 DMs are lost to the rest of the 100+ cohort.
 • No searchable, persistent university knowledge repository exists to archive solved problems.</a:t>
             </a:r>
+            <a:endParaRPr sz="1200" dirty="0">
+              <a:solidFill>
+                <a:srgbClr val="475569"/>
+              </a:solidFill>
+              <a:latin typeface="Calibri"/>
+            </a:endParaRPr>
           </a:p>
         </p:txBody>
       </p:sp>
@@ -9970,7 +10532,6 @@
           <a:lstStyle/>
           <a:p>
             <a:pPr algn="ctr"/>
-            <a:endParaRPr/>
           </a:p>
         </p:txBody>
       </p:sp>
@@ -10014,7 +10575,6 @@
           <a:lstStyle/>
           <a:p>
             <a:pPr algn="ctr"/>
-            <a:endParaRPr/>
           </a:p>
         </p:txBody>
       </p:sp>
@@ -10049,6 +10609,12 @@
               </a:rPr>
               <a:t>Problem 4: Ephemeral Records &amp; Evidence Tampering</a:t>
             </a:r>
+            <a:endParaRPr sz="1400" b="1" dirty="0">
+              <a:solidFill>
+                <a:srgbClr val="8B5CF6"/>
+              </a:solidFill>
+              <a:latin typeface="Calibri"/>
+            </a:endParaRPr>
           </a:p>
           <a:p>
             <a:r>
@@ -10060,6 +10626,12 @@
               </a:rPr>
               <a:t>Lack of Cryptographic Non-Repudiation</a:t>
             </a:r>
+            <a:endParaRPr sz="1200" b="1" dirty="0">
+              <a:solidFill>
+                <a:srgbClr val="1E293B"/>
+              </a:solidFill>
+              <a:latin typeface="Calibri"/>
+            </a:endParaRPr>
           </a:p>
           <a:p>
             <a:pPr>
@@ -10078,6 +10650,12 @@
 • Database logs in standard LMS portals are mutable and vulnerable to timestamp falsification disputes.
 • No independent, cryptographic audit trail exists to resolve submission disputes.</a:t>
             </a:r>
+            <a:endParaRPr sz="1200" dirty="0">
+              <a:solidFill>
+                <a:srgbClr val="475569"/>
+              </a:solidFill>
+              <a:latin typeface="Calibri"/>
+            </a:endParaRPr>
           </a:p>
         </p:txBody>
       </p:sp>
@@ -10121,7 +10699,6 @@
           <a:lstStyle/>
           <a:p>
             <a:pPr algn="ctr"/>
-            <a:endParaRPr/>
           </a:p>
         </p:txBody>
       </p:sp>
@@ -10165,7 +10742,6 @@
           <a:lstStyle/>
           <a:p>
             <a:pPr algn="ctr"/>
-            <a:endParaRPr/>
           </a:p>
         </p:txBody>
       </p:sp>
@@ -10210,25 +10786,25 @@
               </a:rPr>
               <a:t>"How can higher education institutions provide a structured, real-time academic discussion platform that eliminates physical accessibility barriers, verifies faculty authority, and preserves institutional knowledge? (Case Study: UENR)"</a:t>
             </a:r>
+            <a:endParaRPr sz="1100">
+              <a:solidFill>
+                <a:srgbClr val="FFFFFF"/>
+              </a:solidFill>
+              <a:latin typeface="Calibri"/>
+            </a:endParaRPr>
           </a:p>
         </p:txBody>
       </p:sp>
       <p:pic>
         <p:nvPicPr>
-          <p:cNvPr id="26" name="Picture 25">
-            <a:extLst>
-              <a:ext uri="{FF2B5EF4-FFF2-40B4-BE49-F238E27FC236}">
-                <a16:creationId xmlns:a16="http://schemas.microsoft.com/office/drawing/2014/main" id="{5095F1D0-93D6-BC15-AA35-F0B65181FDDE}"/>
-              </a:ext>
-            </a:extLst>
-          </p:cNvPr>
+          <p:cNvPr id="26" name="Picture 25"/>
           <p:cNvPicPr>
             <a:picLocks noChangeAspect="1"/>
           </p:cNvPicPr>
           <p:nvPr/>
         </p:nvPicPr>
         <p:blipFill>
-          <a:blip r:embed="rId2"/>
+          <a:blip r:embed="rId1"/>
           <a:stretch>
             <a:fillRect/>
           </a:stretch>
@@ -10311,7 +10887,6 @@
           <a:lstStyle/>
           <a:p>
             <a:pPr algn="ctr"/>
-            <a:endParaRPr/>
           </a:p>
         </p:txBody>
       </p:sp>
@@ -10355,7 +10930,6 @@
           <a:lstStyle/>
           <a:p>
             <a:pPr algn="ctr"/>
-            <a:endParaRPr/>
           </a:p>
         </p:txBody>
       </p:sp>
@@ -10399,7 +10973,6 @@
           <a:lstStyle/>
           <a:p>
             <a:pPr algn="ctr"/>
-            <a:endParaRPr/>
           </a:p>
         </p:txBody>
       </p:sp>
@@ -10452,6 +11025,12 @@
               </a:rPr>
               <a:t>03</a:t>
             </a:r>
+            <a:endParaRPr sz="2000" b="1">
+              <a:solidFill>
+                <a:srgbClr val="00336A"/>
+              </a:solidFill>
+              <a:latin typeface="Calibri"/>
+            </a:endParaRPr>
           </a:p>
         </p:txBody>
       </p:sp>
@@ -10486,6 +11065,12 @@
               </a:rPr>
               <a:t>Aim &amp; Specific Objectives (Case Study: UENR)</a:t>
             </a:r>
+            <a:endParaRPr sz="2000" b="1">
+              <a:solidFill>
+                <a:srgbClr val="FFFFFF"/>
+              </a:solidFill>
+              <a:latin typeface="Calibri"/>
+            </a:endParaRPr>
           </a:p>
           <a:p>
             <a:r>
@@ -10497,6 +11082,12 @@
               </a:rPr>
               <a:t>Research Scope, Mission Statement, and Five Primary Technical Deliverables</a:t>
             </a:r>
+            <a:endParaRPr sz="1100" i="1">
+              <a:solidFill>
+                <a:srgbClr val="BAE6FD"/>
+              </a:solidFill>
+              <a:latin typeface="Calibri"/>
+            </a:endParaRPr>
           </a:p>
         </p:txBody>
       </p:sp>
@@ -10540,7 +11131,6 @@
           <a:lstStyle/>
           <a:p>
             <a:pPr algn="ctr"/>
-            <a:endParaRPr/>
           </a:p>
         </p:txBody>
       </p:sp>
@@ -10575,6 +11165,12 @@
               </a:rPr>
               <a:t>QCampus Connect | Verified Academic Q&amp;A Forum &amp; Secure Consultation Platform | Case Study: UENR</a:t>
             </a:r>
+            <a:endParaRPr sz="850">
+              <a:solidFill>
+                <a:srgbClr val="475569"/>
+              </a:solidFill>
+              <a:latin typeface="Calibri"/>
+            </a:endParaRPr>
           </a:p>
         </p:txBody>
       </p:sp>
@@ -10610,6 +11206,12 @@
               </a:rPr>
               <a:t>Slide 03 / 08</a:t>
             </a:r>
+            <a:endParaRPr sz="850" b="1">
+              <a:solidFill>
+                <a:srgbClr val="00336A"/>
+              </a:solidFill>
+              <a:latin typeface="Calibri"/>
+            </a:endParaRPr>
           </a:p>
         </p:txBody>
       </p:sp>
@@ -10655,7 +11257,6 @@
           <a:lstStyle/>
           <a:p>
             <a:pPr algn="ctr"/>
-            <a:endParaRPr/>
           </a:p>
         </p:txBody>
       </p:sp>
@@ -10699,7 +11300,6 @@
           <a:lstStyle/>
           <a:p>
             <a:pPr algn="ctr"/>
-            <a:endParaRPr/>
           </a:p>
         </p:txBody>
       </p:sp>
@@ -10743,6 +11343,12 @@
               </a:rPr>
               <a:t>MAIN RESEARCH AIM</a:t>
             </a:r>
+            <a:endParaRPr sz="1400" b="1" dirty="0">
+              <a:solidFill>
+                <a:srgbClr val="00336A"/>
+              </a:solidFill>
+              <a:latin typeface="Calibri"/>
+            </a:endParaRPr>
           </a:p>
           <a:p>
             <a:pPr>
@@ -10795,6 +11401,12 @@
               </a:rPr>
               <a:t>) — a verified academic Q&amp;A and knowledge-sharing platform for higher education institutions (with UENR as the pilot case study) where students ask questions publicly, verified faculty provide authoritative guidance, and interactions carry cryptographic trust.</a:t>
             </a:r>
+            <a:endParaRPr sz="1200" dirty="0">
+              <a:solidFill>
+                <a:srgbClr val="1E293B"/>
+              </a:solidFill>
+              <a:latin typeface="Calibri"/>
+            </a:endParaRPr>
           </a:p>
         </p:txBody>
       </p:sp>
@@ -10840,7 +11452,6 @@
           <a:lstStyle/>
           <a:p>
             <a:pPr algn="ctr"/>
-            <a:endParaRPr/>
           </a:p>
         </p:txBody>
       </p:sp>
@@ -10893,6 +11504,12 @@
               </a:rPr>
               <a:t>PRIMARY WORKSPACE</a:t>
             </a:r>
+            <a:endParaRPr sz="1200" b="1" dirty="0">
+              <a:solidFill>
+                <a:srgbClr val="FFFFFF"/>
+              </a:solidFill>
+              <a:latin typeface="Calibri"/>
+            </a:endParaRPr>
           </a:p>
         </p:txBody>
       </p:sp>
@@ -10927,6 +11544,12 @@
               </a:rPr>
               <a:t>Obj 1: Real-Time Academic Q&amp;A</a:t>
             </a:r>
+            <a:endParaRPr sz="1100" b="1" dirty="0">
+              <a:solidFill>
+                <a:srgbClr val="00336A"/>
+              </a:solidFill>
+              <a:latin typeface="Calibri"/>
+            </a:endParaRPr>
           </a:p>
           <a:p>
             <a:pPr>
@@ -10943,6 +11566,12 @@
               </a:rPr>
               <a:t>Build a structured discussion forum categorized by Department (e.g., Computer Science) and Subject topics (e.g., Cryptography, OS, AI) with sub-50ms reactive WebSocket synchronization.</a:t>
             </a:r>
+            <a:endParaRPr sz="1300" dirty="0">
+              <a:solidFill>
+                <a:srgbClr val="475569"/>
+              </a:solidFill>
+              <a:latin typeface="Calibri"/>
+            </a:endParaRPr>
           </a:p>
         </p:txBody>
       </p:sp>
@@ -10988,7 +11617,6 @@
           <a:lstStyle/>
           <a:p>
             <a:pPr algn="ctr"/>
-            <a:endParaRPr/>
           </a:p>
         </p:txBody>
       </p:sp>
@@ -11090,6 +11718,12 @@
               </a:rPr>
               <a:t>Obj 2: Authority &amp; Field Badges</a:t>
             </a:r>
+            <a:endParaRPr sz="1100" b="1" dirty="0">
+              <a:solidFill>
+                <a:srgbClr val="00336A"/>
+              </a:solidFill>
+              <a:latin typeface="Calibri"/>
+            </a:endParaRPr>
           </a:p>
           <a:p>
             <a:pPr>
@@ -11106,6 +11740,12 @@
               </a:rPr>
               <a:t>Cryptographically bind real institutional credentials (Student Index / Staff ID) and display verified departmental badges (CS) and specialization labels (Cryptography) on every faculty response.</a:t>
             </a:r>
+            <a:endParaRPr sz="1300" dirty="0">
+              <a:solidFill>
+                <a:srgbClr val="475569"/>
+              </a:solidFill>
+              <a:latin typeface="Calibri"/>
+            </a:endParaRPr>
           </a:p>
         </p:txBody>
       </p:sp>
@@ -11151,7 +11791,6 @@
           <a:lstStyle/>
           <a:p>
             <a:pPr algn="ctr"/>
-            <a:endParaRPr/>
           </a:p>
         </p:txBody>
       </p:sp>
@@ -11204,6 +11843,12 @@
               </a:rPr>
               <a:t>SECURE SUB-FEATURE</a:t>
             </a:r>
+            <a:endParaRPr sz="1200" b="1" dirty="0">
+              <a:solidFill>
+                <a:srgbClr val="FFFFFF"/>
+              </a:solidFill>
+              <a:latin typeface="Calibri"/>
+            </a:endParaRPr>
           </a:p>
         </p:txBody>
       </p:sp>
@@ -11238,6 +11883,12 @@
               </a:rPr>
               <a:t>Obj 3: 1-on-1 Encrypted DMs</a:t>
             </a:r>
+            <a:endParaRPr sz="1100" b="1" dirty="0">
+              <a:solidFill>
+                <a:srgbClr val="00336A"/>
+              </a:solidFill>
+              <a:latin typeface="Calibri"/>
+            </a:endParaRPr>
           </a:p>
           <a:p>
             <a:pPr>
@@ -11254,6 +11905,12 @@
               </a:rPr>
               <a:t>Enable private student-faculty consultation initiated directly from Q&amp;A threads using client-side RSA-OAEP 2048 &amp; AES-GCM 256 encryption, paired with an educational BB84 QKD simulator.</a:t>
             </a:r>
+            <a:endParaRPr sz="1300" dirty="0">
+              <a:solidFill>
+                <a:srgbClr val="475569"/>
+              </a:solidFill>
+              <a:latin typeface="Calibri"/>
+            </a:endParaRPr>
           </a:p>
         </p:txBody>
       </p:sp>
@@ -11299,7 +11956,6 @@
           <a:lstStyle/>
           <a:p>
             <a:pPr algn="ctr"/>
-            <a:endParaRPr/>
           </a:p>
         </p:txBody>
       </p:sp>
@@ -11352,6 +12008,12 @@
               </a:rPr>
               <a:t>IMMUTABLE TRUST</a:t>
             </a:r>
+            <a:endParaRPr sz="1200" b="1" dirty="0">
+              <a:solidFill>
+                <a:srgbClr val="FFFFFF"/>
+              </a:solidFill>
+              <a:latin typeface="Calibri"/>
+            </a:endParaRPr>
           </a:p>
         </p:txBody>
       </p:sp>
@@ -11386,6 +12048,12 @@
               </a:rPr>
               <a:t>Obj 4: Blockchain Audit Trail</a:t>
             </a:r>
+            <a:endParaRPr sz="1100" b="1" dirty="0">
+              <a:solidFill>
+                <a:srgbClr val="00336A"/>
+              </a:solidFill>
+              <a:latin typeface="Calibri"/>
+            </a:endParaRPr>
           </a:p>
           <a:p>
             <a:pPr>
@@ -11402,6 +12070,12 @@
               </a:rPr>
               <a:t>Anchor SHA-256 digests of answers and submissions to a permissioned Hyperledger Besu blockchain (QBFT, zero-gas smart contracts) for permanent non-repudiation and dispute resolution.</a:t>
             </a:r>
+            <a:endParaRPr sz="1300" dirty="0">
+              <a:solidFill>
+                <a:srgbClr val="475569"/>
+              </a:solidFill>
+              <a:latin typeface="Calibri"/>
+            </a:endParaRPr>
           </a:p>
         </p:txBody>
       </p:sp>
@@ -11447,7 +12121,6 @@
           <a:lstStyle/>
           <a:p>
             <a:pPr algn="ctr"/>
-            <a:endParaRPr/>
           </a:p>
         </p:txBody>
       </p:sp>
@@ -11500,6 +12173,12 @@
               </a:rPr>
               <a:t>INSTITUTIONAL CONTROL</a:t>
             </a:r>
+            <a:endParaRPr sz="1200" b="1" dirty="0">
+              <a:solidFill>
+                <a:srgbClr val="FFFFFF"/>
+              </a:solidFill>
+              <a:latin typeface="Calibri"/>
+            </a:endParaRPr>
           </a:p>
         </p:txBody>
       </p:sp>
@@ -11534,6 +12213,12 @@
               </a:rPr>
               <a:t>Obj 5: Admin &amp; Governance Desk</a:t>
             </a:r>
+            <a:endParaRPr sz="1100" b="1" dirty="0">
+              <a:solidFill>
+                <a:srgbClr val="00336A"/>
+              </a:solidFill>
+              <a:latin typeface="Calibri"/>
+            </a:endParaRPr>
           </a:p>
           <a:p>
             <a:pPr>
@@ -11550,6 +12235,12 @@
               </a:rPr>
               <a:t>Provide administrative tooling for departmental routing, lecturer credential approval, and cryptographic dispute audit verification via real student index/staff queries.</a:t>
             </a:r>
+            <a:endParaRPr sz="1300" dirty="0">
+              <a:solidFill>
+                <a:srgbClr val="475569"/>
+              </a:solidFill>
+              <a:latin typeface="Calibri"/>
+            </a:endParaRPr>
           </a:p>
         </p:txBody>
       </p:sp>
@@ -11593,7 +12284,6 @@
           <a:lstStyle/>
           <a:p>
             <a:pPr algn="ctr"/>
-            <a:endParaRPr/>
           </a:p>
         </p:txBody>
       </p:sp>
@@ -11637,7 +12327,6 @@
           <a:lstStyle/>
           <a:p>
             <a:pPr algn="ctr"/>
-            <a:endParaRPr/>
           </a:p>
         </p:txBody>
       </p:sp>
@@ -11700,25 +12389,25 @@
               </a:rPr>
               <a:t> campus workspace. Direct messaging is a follow-up tool. Blockchain provides the proof."</a:t>
             </a:r>
+            <a:endParaRPr sz="1100" dirty="0">
+              <a:solidFill>
+                <a:srgbClr val="FFFFFF"/>
+              </a:solidFill>
+              <a:latin typeface="Calibri"/>
+            </a:endParaRPr>
           </a:p>
         </p:txBody>
       </p:sp>
       <p:pic>
         <p:nvPicPr>
-          <p:cNvPr id="32" name="Picture 31">
-            <a:extLst>
-              <a:ext uri="{FF2B5EF4-FFF2-40B4-BE49-F238E27FC236}">
-                <a16:creationId xmlns:a16="http://schemas.microsoft.com/office/drawing/2014/main" id="{C780D345-0DC2-74B9-21BA-264531B5D2D9}"/>
-              </a:ext>
-            </a:extLst>
-          </p:cNvPr>
+          <p:cNvPr id="32" name="Picture 31"/>
           <p:cNvPicPr>
             <a:picLocks noChangeAspect="1"/>
           </p:cNvPicPr>
           <p:nvPr/>
         </p:nvPicPr>
         <p:blipFill>
-          <a:blip r:embed="rId2"/>
+          <a:blip r:embed="rId1"/>
           <a:stretch>
             <a:fillRect/>
           </a:stretch>
@@ -11801,7 +12490,6 @@
           <a:lstStyle/>
           <a:p>
             <a:pPr algn="ctr"/>
-            <a:endParaRPr/>
           </a:p>
         </p:txBody>
       </p:sp>
@@ -11845,7 +12533,6 @@
           <a:lstStyle/>
           <a:p>
             <a:pPr algn="ctr"/>
-            <a:endParaRPr/>
           </a:p>
         </p:txBody>
       </p:sp>
@@ -11889,7 +12576,6 @@
           <a:lstStyle/>
           <a:p>
             <a:pPr algn="ctr"/>
-            <a:endParaRPr/>
           </a:p>
         </p:txBody>
       </p:sp>
@@ -11942,6 +12628,12 @@
               </a:rPr>
               <a:t>04</a:t>
             </a:r>
+            <a:endParaRPr sz="2000" b="1">
+              <a:solidFill>
+                <a:srgbClr val="00336A"/>
+              </a:solidFill>
+              <a:latin typeface="Calibri"/>
+            </a:endParaRPr>
           </a:p>
         </p:txBody>
       </p:sp>
@@ -11976,6 +12668,12 @@
               </a:rPr>
               <a:t>Related Work &amp; Platform Comparison</a:t>
             </a:r>
+            <a:endParaRPr sz="2000" b="1">
+              <a:solidFill>
+                <a:srgbClr val="FFFFFF"/>
+              </a:solidFill>
+              <a:latin typeface="Calibri"/>
+            </a:endParaRPr>
           </a:p>
           <a:p>
             <a:r>
@@ -11987,6 +12685,12 @@
               </a:rPr>
               <a:t>Comparative Analysis of Existing Higher Education Communication Channels vs. QCampus Connect</a:t>
             </a:r>
+            <a:endParaRPr sz="1100" i="1">
+              <a:solidFill>
+                <a:srgbClr val="BAE6FD"/>
+              </a:solidFill>
+              <a:latin typeface="Calibri"/>
+            </a:endParaRPr>
           </a:p>
         </p:txBody>
       </p:sp>
@@ -12030,7 +12734,6 @@
           <a:lstStyle/>
           <a:p>
             <a:pPr algn="ctr"/>
-            <a:endParaRPr/>
           </a:p>
         </p:txBody>
       </p:sp>
@@ -12065,6 +12768,12 @@
               </a:rPr>
               <a:t>QCampus Connect | Verified Academic Q&amp;A Forum &amp; Secure Consultation Platform | Case Study: UENR</a:t>
             </a:r>
+            <a:endParaRPr sz="850">
+              <a:solidFill>
+                <a:srgbClr val="475569"/>
+              </a:solidFill>
+              <a:latin typeface="Calibri"/>
+            </a:endParaRPr>
           </a:p>
         </p:txBody>
       </p:sp>
@@ -12100,6 +12809,12 @@
               </a:rPr>
               <a:t>Slide 04 / 08</a:t>
             </a:r>
+            <a:endParaRPr sz="850" b="1">
+              <a:solidFill>
+                <a:srgbClr val="00336A"/>
+              </a:solidFill>
+              <a:latin typeface="Calibri"/>
+            </a:endParaRPr>
           </a:p>
         </p:txBody>
       </p:sp>
@@ -12145,7 +12860,6 @@
           <a:lstStyle/>
           <a:p>
             <a:pPr algn="ctr"/>
-            <a:endParaRPr/>
           </a:p>
         </p:txBody>
       </p:sp>
@@ -12189,7 +12903,6 @@
           <a:lstStyle/>
           <a:p>
             <a:pPr algn="ctr"/>
-            <a:endParaRPr/>
           </a:p>
         </p:txBody>
       </p:sp>
@@ -12233,6 +12946,12 @@
               </a:rPr>
               <a:t>  (Consumer Instant Messaging)</a:t>
             </a:r>
+            <a:endParaRPr sz="1400" i="1" dirty="0">
+              <a:solidFill>
+                <a:srgbClr val="475569"/>
+              </a:solidFill>
+              <a:latin typeface="Calibri"/>
+            </a:endParaRPr>
           </a:p>
           <a:p>
             <a:pPr>
@@ -12250,6 +12969,12 @@
               <a:t>• Strengths: Sub-second message delivery; transit encryption (Signal Protocol); ubiquitous adoption.
 • Critical Academic Gaps: Unstructured, noisy chat streams; messages easily deleted ('Delete for Everyone'); zero institutional role verification; completely untrusted for formal academic audit.</a:t>
             </a:r>
+            <a:endParaRPr sz="1400" dirty="0">
+              <a:solidFill>
+                <a:srgbClr val="1E293B"/>
+              </a:solidFill>
+              <a:latin typeface="Calibri"/>
+            </a:endParaRPr>
           </a:p>
         </p:txBody>
       </p:sp>
@@ -12295,7 +13020,6 @@
           <a:lstStyle/>
           <a:p>
             <a:pPr algn="ctr"/>
-            <a:endParaRPr/>
           </a:p>
         </p:txBody>
       </p:sp>
@@ -12339,7 +13063,6 @@
           <a:lstStyle/>
           <a:p>
             <a:pPr algn="ctr"/>
-            <a:endParaRPr/>
           </a:p>
         </p:txBody>
       </p:sp>
@@ -12383,6 +13106,12 @@
               </a:rPr>
               <a:t>  (Public Discussion Forums)</a:t>
             </a:r>
+            <a:endParaRPr sz="1400" i="1" dirty="0">
+              <a:solidFill>
+                <a:srgbClr val="475569"/>
+              </a:solidFill>
+              <a:latin typeface="Calibri"/>
+            </a:endParaRPr>
           </a:p>
           <a:p>
             <a:pPr>
@@ -12400,6 +13129,12 @@
               <a:t>• Strengths: Structured Q&amp;A threading; community voting; topic tags.
 • Critical Academic Gaps: Completely detached from university curricula; pseudonymous accounts; upvote karma rewards popularity over academic expertise; posts can be silently edited with no proof.</a:t>
             </a:r>
+            <a:endParaRPr sz="1400" dirty="0">
+              <a:solidFill>
+                <a:srgbClr val="1E293B"/>
+              </a:solidFill>
+              <a:latin typeface="Calibri"/>
+            </a:endParaRPr>
           </a:p>
         </p:txBody>
       </p:sp>
@@ -12445,7 +13180,6 @@
           <a:lstStyle/>
           <a:p>
             <a:pPr algn="ctr"/>
-            <a:endParaRPr/>
           </a:p>
         </p:txBody>
       </p:sp>
@@ -12489,7 +13223,6 @@
           <a:lstStyle/>
           <a:p>
             <a:pPr algn="ctr"/>
-            <a:endParaRPr/>
           </a:p>
         </p:txBody>
       </p:sp>
@@ -12533,6 +13266,12 @@
               </a:rPr>
               <a:t>  (Coursework Management (VLE))</a:t>
             </a:r>
+            <a:endParaRPr sz="1400" i="1" dirty="0">
+              <a:solidFill>
+                <a:srgbClr val="475569"/>
+              </a:solidFill>
+              <a:latin typeface="Calibri"/>
+            </a:endParaRPr>
           </a:p>
           <a:p>
             <a:pPr>
@@ -12550,6 +13289,12 @@
               <a:t>• Strengths: Assignment submission modules; gradebook tracking; course file hosting.
 • Critical Academic Gaps: Static file repositories; lacks real-time interactive peer-faculty discussions; relies on mutable SQL database logs without cryptographic non-repudiation.</a:t>
             </a:r>
+            <a:endParaRPr sz="1400" dirty="0">
+              <a:solidFill>
+                <a:srgbClr val="1E293B"/>
+              </a:solidFill>
+              <a:latin typeface="Calibri"/>
+            </a:endParaRPr>
           </a:p>
         </p:txBody>
       </p:sp>
@@ -12595,7 +13340,6 @@
           <a:lstStyle/>
           <a:p>
             <a:pPr algn="ctr"/>
-            <a:endParaRPr/>
           </a:p>
         </p:txBody>
       </p:sp>
@@ -12639,7 +13383,6 @@
           <a:lstStyle/>
           <a:p>
             <a:pPr algn="ctr"/>
-            <a:endParaRPr/>
           </a:p>
         </p:txBody>
       </p:sp>
@@ -12683,6 +13426,12 @@
               </a:rPr>
               <a:t>  (Enterprise Team Collaboration)</a:t>
             </a:r>
+            <a:endParaRPr sz="1400" i="1" dirty="0">
+              <a:solidFill>
+                <a:srgbClr val="475569"/>
+              </a:solidFill>
+              <a:latin typeface="Calibri"/>
+            </a:endParaRPr>
           </a:p>
           <a:p>
             <a:pPr>
@@ -12700,6 +13449,12 @@
               <a:t>• Strengths: Organized departmental channels; file sharing; role-based access control.
 • Critical Academic Gaps: Expensive licensing; centralized server custody (admins can purge or edit records); no independent client-side encryption or blockchain proof.</a:t>
             </a:r>
+            <a:endParaRPr sz="1400" dirty="0">
+              <a:solidFill>
+                <a:srgbClr val="1E293B"/>
+              </a:solidFill>
+              <a:latin typeface="Calibri"/>
+            </a:endParaRPr>
           </a:p>
         </p:txBody>
       </p:sp>
@@ -12743,7 +13498,6 @@
           <a:lstStyle/>
           <a:p>
             <a:pPr algn="ctr"/>
-            <a:endParaRPr/>
           </a:p>
         </p:txBody>
       </p:sp>
@@ -12787,7 +13541,6 @@
           <a:lstStyle/>
           <a:p>
             <a:pPr algn="ctr"/>
-            <a:endParaRPr/>
           </a:p>
         </p:txBody>
       </p:sp>
@@ -12841,25 +13594,25 @@
               </a:rPr>
               <a:t> Connect uniquely unifies: (1) Sub-50ms reactive WebSocket discussion (Convex), (2) Institutional identity &amp; specialization badges, (3) Client-encrypted 1-on-1 consultation (RSA/AES), and (4) Zero-gas immutable blockchain provenance (Hyperledger Besu).</a:t>
             </a:r>
+            <a:endParaRPr sz="1300" dirty="0">
+              <a:solidFill>
+                <a:srgbClr val="FFFFFF"/>
+              </a:solidFill>
+              <a:latin typeface="Calibri"/>
+            </a:endParaRPr>
           </a:p>
         </p:txBody>
       </p:sp>
       <p:pic>
         <p:nvPicPr>
-          <p:cNvPr id="26" name="Picture 25">
-            <a:extLst>
-              <a:ext uri="{FF2B5EF4-FFF2-40B4-BE49-F238E27FC236}">
-                <a16:creationId xmlns:a16="http://schemas.microsoft.com/office/drawing/2014/main" id="{10DF7C6D-EEF9-AF4D-DB43-E7F77288D6D7}"/>
-              </a:ext>
-            </a:extLst>
-          </p:cNvPr>
+          <p:cNvPr id="26" name="Picture 25"/>
           <p:cNvPicPr>
             <a:picLocks noChangeAspect="1"/>
           </p:cNvPicPr>
           <p:nvPr/>
         </p:nvPicPr>
         <p:blipFill>
-          <a:blip r:embed="rId2"/>
+          <a:blip r:embed="rId1"/>
           <a:stretch>
             <a:fillRect/>
           </a:stretch>
@@ -12942,7 +13695,6 @@
           <a:lstStyle/>
           <a:p>
             <a:pPr algn="ctr"/>
-            <a:endParaRPr/>
           </a:p>
         </p:txBody>
       </p:sp>
@@ -12986,7 +13738,6 @@
           <a:lstStyle/>
           <a:p>
             <a:pPr algn="ctr"/>
-            <a:endParaRPr/>
           </a:p>
         </p:txBody>
       </p:sp>
@@ -13030,7 +13781,6 @@
           <a:lstStyle/>
           <a:p>
             <a:pPr algn="ctr"/>
-            <a:endParaRPr/>
           </a:p>
         </p:txBody>
       </p:sp>
@@ -13083,6 +13833,12 @@
               </a:rPr>
               <a:t>05</a:t>
             </a:r>
+            <a:endParaRPr sz="2000" b="1">
+              <a:solidFill>
+                <a:srgbClr val="00336A"/>
+              </a:solidFill>
+              <a:latin typeface="Calibri"/>
+            </a:endParaRPr>
           </a:p>
         </p:txBody>
       </p:sp>
@@ -13117,6 +13873,12 @@
               </a:rPr>
               <a:t>Methodology &amp; System Architecture</a:t>
             </a:r>
+            <a:endParaRPr sz="2000" b="1">
+              <a:solidFill>
+                <a:srgbClr val="FFFFFF"/>
+              </a:solidFill>
+              <a:latin typeface="Calibri"/>
+            </a:endParaRPr>
           </a:p>
           <a:p>
             <a:r>
@@ -13128,6 +13890,12 @@
               </a:rPr>
               <a:t>Three-Tier Enterprise Architecture: Client-Side WebCrypto, Real-Time Serverless &amp; Blockchain Layer</a:t>
             </a:r>
+            <a:endParaRPr sz="1100" i="1">
+              <a:solidFill>
+                <a:srgbClr val="BAE6FD"/>
+              </a:solidFill>
+              <a:latin typeface="Calibri"/>
+            </a:endParaRPr>
           </a:p>
         </p:txBody>
       </p:sp>
@@ -13171,7 +13939,6 @@
           <a:lstStyle/>
           <a:p>
             <a:pPr algn="ctr"/>
-            <a:endParaRPr/>
           </a:p>
         </p:txBody>
       </p:sp>
@@ -13206,6 +13973,12 @@
               </a:rPr>
               <a:t>QCampus Connect | Verified Academic Q&amp;A Forum &amp; Secure Consultation Platform | Case Study: UENR</a:t>
             </a:r>
+            <a:endParaRPr sz="850">
+              <a:solidFill>
+                <a:srgbClr val="475569"/>
+              </a:solidFill>
+              <a:latin typeface="Calibri"/>
+            </a:endParaRPr>
           </a:p>
         </p:txBody>
       </p:sp>
@@ -13241,6 +14014,12 @@
               </a:rPr>
               <a:t>Slide 05 / 08</a:t>
             </a:r>
+            <a:endParaRPr sz="850" b="1">
+              <a:solidFill>
+                <a:srgbClr val="00336A"/>
+              </a:solidFill>
+              <a:latin typeface="Calibri"/>
+            </a:endParaRPr>
           </a:p>
         </p:txBody>
       </p:sp>
@@ -13286,7 +14065,6 @@
           <a:lstStyle/>
           <a:p>
             <a:pPr algn="ctr"/>
-            <a:endParaRPr/>
           </a:p>
         </p:txBody>
       </p:sp>
@@ -13330,7 +14108,6 @@
           <a:lstStyle/>
           <a:p>
             <a:pPr algn="ctr"/>
-            <a:endParaRPr/>
           </a:p>
         </p:txBody>
       </p:sp>
@@ -13365,6 +14142,12 @@
               </a:rPr>
               <a:t>1. PRESENTATION LAYER (Browser — React 19 SPA)</a:t>
             </a:r>
+            <a:endParaRPr sz="1100" b="1" dirty="0">
+              <a:solidFill>
+                <a:srgbClr val="00336A"/>
+              </a:solidFill>
+              <a:latin typeface="Calibri"/>
+            </a:endParaRPr>
           </a:p>
           <a:p>
             <a:pPr>
@@ -13401,6 +14184,12 @@
               </a:rPr>
               <a:t>.</a:t>
             </a:r>
+            <a:endParaRPr sz="1200" dirty="0">
+              <a:solidFill>
+                <a:srgbClr val="1E293B"/>
+              </a:solidFill>
+              <a:latin typeface="Calibri"/>
+            </a:endParaRPr>
           </a:p>
         </p:txBody>
       </p:sp>
@@ -13446,7 +14235,6 @@
           <a:lstStyle/>
           <a:p>
             <a:pPr algn="ctr"/>
-            <a:endParaRPr/>
           </a:p>
         </p:txBody>
       </p:sp>
@@ -13490,7 +14278,6 @@
           <a:lstStyle/>
           <a:p>
             <a:pPr algn="ctr"/>
-            <a:endParaRPr/>
           </a:p>
         </p:txBody>
       </p:sp>
@@ -13525,6 +14312,12 @@
               </a:rPr>
               <a:t>2. APPLICATION LAYER (Convex Serverless Platform)</a:t>
             </a:r>
+            <a:endParaRPr sz="1100" b="1" dirty="0">
+              <a:solidFill>
+                <a:srgbClr val="1E90FF"/>
+              </a:solidFill>
+              <a:latin typeface="Calibri"/>
+            </a:endParaRPr>
           </a:p>
           <a:p>
             <a:pPr>
@@ -13679,6 +14472,12 @@
               </a:rPr>
               <a:t>.</a:t>
             </a:r>
+            <a:endParaRPr sz="1050" dirty="0">
+              <a:solidFill>
+                <a:srgbClr val="1E293B"/>
+              </a:solidFill>
+              <a:latin typeface="Calibri"/>
+            </a:endParaRPr>
           </a:p>
         </p:txBody>
       </p:sp>
@@ -13724,7 +14523,6 @@
           <a:lstStyle/>
           <a:p>
             <a:pPr algn="ctr"/>
-            <a:endParaRPr/>
           </a:p>
         </p:txBody>
       </p:sp>
@@ -13768,7 +14566,6 @@
           <a:lstStyle/>
           <a:p>
             <a:pPr algn="ctr"/>
-            <a:endParaRPr/>
           </a:p>
         </p:txBody>
       </p:sp>
@@ -13803,6 +14600,12 @@
               </a:rPr>
               <a:t>3. VERIFICATION LAYER (Hyperledger Besu + Solidity)</a:t>
             </a:r>
+            <a:endParaRPr sz="1100" b="1" dirty="0">
+              <a:solidFill>
+                <a:srgbClr val="00509E"/>
+              </a:solidFill>
+              <a:latin typeface="Calibri"/>
+            </a:endParaRPr>
           </a:p>
           <a:p>
             <a:pPr>
@@ -13911,6 +14714,12 @@
               <a:t>).
 • Audit Trail: Asynchronous SHA-256 digest anchoring (~0.3-0.5s block write) for non-repudiation.</a:t>
             </a:r>
+            <a:endParaRPr sz="1200" dirty="0">
+              <a:solidFill>
+                <a:srgbClr val="1E293B"/>
+              </a:solidFill>
+              <a:latin typeface="Calibri"/>
+            </a:endParaRPr>
           </a:p>
         </p:txBody>
       </p:sp>
@@ -13957,7 +14766,6 @@
           <a:lstStyle/>
           <a:p>
             <a:pPr algn="ctr"/>
-            <a:endParaRPr/>
           </a:p>
         </p:txBody>
       </p:sp>
@@ -14010,6 +14818,12 @@
               </a:rPr>
               <a:t>  THREE-TIER SYSTEM ARCHITECTURE &amp; CRYPTO FLOW</a:t>
             </a:r>
+            <a:endParaRPr sz="1200" b="1" dirty="0">
+              <a:solidFill>
+                <a:srgbClr val="FFFFFF"/>
+              </a:solidFill>
+              <a:latin typeface="Calibri"/>
+            </a:endParaRPr>
           </a:p>
         </p:txBody>
       </p:sp>
@@ -14063,6 +14877,12 @@
               </a:rPr>
               <a:t> &amp; Asynchronous Besu Blockchain Anchoring</a:t>
             </a:r>
+            <a:endParaRPr sz="1600" b="1" i="1" dirty="0">
+              <a:solidFill>
+                <a:srgbClr val="00509E"/>
+              </a:solidFill>
+              <a:latin typeface="Calibri"/>
+            </a:endParaRPr>
           </a:p>
           <a:p>
             <a:pPr>
@@ -14097,6 +14917,12 @@
               </a:rPr>
               <a:t>.</a:t>
             </a:r>
+            <a:endParaRPr sz="1400" dirty="0">
+              <a:solidFill>
+                <a:srgbClr val="1E293B"/>
+              </a:solidFill>
+              <a:latin typeface="Calibri"/>
+            </a:endParaRPr>
           </a:p>
           <a:p>
             <a:pPr>
@@ -14131,6 +14957,12 @@
               </a:rPr>
               <a:t> sync questions and answers to all active clients in &lt;50ms.</a:t>
             </a:r>
+            <a:endParaRPr sz="1400" dirty="0">
+              <a:solidFill>
+                <a:srgbClr val="1E293B"/>
+              </a:solidFill>
+              <a:latin typeface="Calibri"/>
+            </a:endParaRPr>
           </a:p>
           <a:p>
             <a:pPr>
@@ -14165,6 +14997,12 @@
               </a:rPr>
               <a:t>.</a:t>
             </a:r>
+            <a:endParaRPr sz="1400" dirty="0">
+              <a:solidFill>
+                <a:srgbClr val="1E293B"/>
+              </a:solidFill>
+              <a:latin typeface="Calibri"/>
+            </a:endParaRPr>
           </a:p>
           <a:p>
             <a:pPr>
@@ -14181,6 +15019,12 @@
               </a:rPr>
               <a:t>• Admin Audit Desk: Independent verifier queries smart contract to prove authenticity without trusting server.</a:t>
             </a:r>
+            <a:endParaRPr sz="1400" dirty="0">
+              <a:solidFill>
+                <a:srgbClr val="1E293B"/>
+              </a:solidFill>
+              <a:latin typeface="Calibri"/>
+            </a:endParaRPr>
           </a:p>
           <a:p>
             <a:pPr>
@@ -14197,6 +15041,12 @@
               </a:rPr>
               <a:t>• Zero Gas Fees: QBFT consensus on private Besu network eliminates all transaction costs for university.</a:t>
             </a:r>
+            <a:endParaRPr sz="1400" dirty="0">
+              <a:solidFill>
+                <a:srgbClr val="1E293B"/>
+              </a:solidFill>
+              <a:latin typeface="Calibri"/>
+            </a:endParaRPr>
           </a:p>
         </p:txBody>
       </p:sp>
@@ -14240,7 +15090,6 @@
           <a:lstStyle/>
           <a:p>
             <a:pPr algn="ctr"/>
-            <a:endParaRPr/>
           </a:p>
         </p:txBody>
       </p:sp>
@@ -14284,7 +15133,6 @@
           <a:lstStyle/>
           <a:p>
             <a:pPr algn="ctr"/>
-            <a:endParaRPr/>
           </a:p>
         </p:txBody>
       </p:sp>
@@ -14347,25 +15195,25 @@
               </a:rPr>
               <a:t>, while blockchain audit logging occurs asynchronously in the background (~0.3-0.5s) without blocking the UI or charging gas fees.</a:t>
             </a:r>
+            <a:endParaRPr sz="1200" dirty="0">
+              <a:solidFill>
+                <a:srgbClr val="FFFFFF"/>
+              </a:solidFill>
+              <a:latin typeface="Calibri"/>
+            </a:endParaRPr>
           </a:p>
         </p:txBody>
       </p:sp>
       <p:pic>
         <p:nvPicPr>
-          <p:cNvPr id="26" name="Picture 25">
-            <a:extLst>
-              <a:ext uri="{FF2B5EF4-FFF2-40B4-BE49-F238E27FC236}">
-                <a16:creationId xmlns:a16="http://schemas.microsoft.com/office/drawing/2014/main" id="{CB1E3B97-5BA2-D0E8-9337-7AFAA7E820FA}"/>
-              </a:ext>
-            </a:extLst>
-          </p:cNvPr>
+          <p:cNvPr id="26" name="Picture 25"/>
           <p:cNvPicPr>
             <a:picLocks noChangeAspect="1"/>
           </p:cNvPicPr>
           <p:nvPr/>
         </p:nvPicPr>
         <p:blipFill>
-          <a:blip r:embed="rId2"/>
+          <a:blip r:embed="rId1"/>
           <a:stretch>
             <a:fillRect/>
           </a:stretch>
@@ -14448,7 +15296,6 @@
           <a:lstStyle/>
           <a:p>
             <a:pPr algn="ctr"/>
-            <a:endParaRPr/>
           </a:p>
         </p:txBody>
       </p:sp>
@@ -14492,7 +15339,6 @@
           <a:lstStyle/>
           <a:p>
             <a:pPr algn="ctr"/>
-            <a:endParaRPr/>
           </a:p>
         </p:txBody>
       </p:sp>
@@ -14536,7 +15382,6 @@
           <a:lstStyle/>
           <a:p>
             <a:pPr algn="ctr"/>
-            <a:endParaRPr/>
           </a:p>
         </p:txBody>
       </p:sp>
@@ -14589,6 +15434,12 @@
               </a:rPr>
               <a:t>06</a:t>
             </a:r>
+            <a:endParaRPr sz="2000" b="1">
+              <a:solidFill>
+                <a:srgbClr val="00336A"/>
+              </a:solidFill>
+              <a:latin typeface="Calibri"/>
+            </a:endParaRPr>
           </a:p>
         </p:txBody>
       </p:sp>
@@ -14623,6 +15474,12 @@
               </a:rPr>
               <a:t>Academic Q&amp;A &amp; Real-World Identity Workflow</a:t>
             </a:r>
+            <a:endParaRPr sz="2000" b="1">
+              <a:solidFill>
+                <a:srgbClr val="FFFFFF"/>
+              </a:solidFill>
+              <a:latin typeface="Calibri"/>
+            </a:endParaRPr>
           </a:p>
           <a:p>
             <a:r>
@@ -14634,6 +15491,12 @@
               </a:rPr>
               <a:t>End-to-End Six-Step Cryptographic Verification &amp; Consultation Lifecycle (From Forum Question to Audit Proof)</a:t>
             </a:r>
+            <a:endParaRPr sz="1100" i="1">
+              <a:solidFill>
+                <a:srgbClr val="BAE6FD"/>
+              </a:solidFill>
+              <a:latin typeface="Calibri"/>
+            </a:endParaRPr>
           </a:p>
         </p:txBody>
       </p:sp>
@@ -14677,7 +15540,6 @@
           <a:lstStyle/>
           <a:p>
             <a:pPr algn="ctr"/>
-            <a:endParaRPr/>
           </a:p>
         </p:txBody>
       </p:sp>
@@ -14712,6 +15574,12 @@
               </a:rPr>
               <a:t>QCampus Connect | Verified Academic Q&amp;A Forum &amp; Secure Consultation Platform | Case Study: UENR</a:t>
             </a:r>
+            <a:endParaRPr sz="850">
+              <a:solidFill>
+                <a:srgbClr val="475569"/>
+              </a:solidFill>
+              <a:latin typeface="Calibri"/>
+            </a:endParaRPr>
           </a:p>
         </p:txBody>
       </p:sp>
@@ -14747,6 +15615,12 @@
               </a:rPr>
               <a:t>Slide 06 / 08</a:t>
             </a:r>
+            <a:endParaRPr sz="850" b="1">
+              <a:solidFill>
+                <a:srgbClr val="00336A"/>
+              </a:solidFill>
+              <a:latin typeface="Calibri"/>
+            </a:endParaRPr>
           </a:p>
         </p:txBody>
       </p:sp>
@@ -14792,7 +15666,6 @@
           <a:lstStyle/>
           <a:p>
             <a:pPr algn="ctr"/>
-            <a:endParaRPr/>
           </a:p>
         </p:txBody>
       </p:sp>
@@ -14836,6 +15709,12 @@
               </a:rPr>
               <a:t>Six-Step End-to-End Verification Lifecycle</a:t>
             </a:r>
+            <a:endParaRPr sz="1600" b="1" dirty="0">
+              <a:solidFill>
+                <a:srgbClr val="00336A"/>
+              </a:solidFill>
+              <a:latin typeface="Calibri"/>
+            </a:endParaRPr>
           </a:p>
           <a:p>
             <a:pPr>
@@ -14861,6 +15740,12 @@
               </a:rPr>
               <a:t>Student posts question categorized by Department (e.g. Computer Science) and Topic tag (e.g. Cryptography). Thread is indexed publicly for all peers to study.</a:t>
             </a:r>
+            <a:endParaRPr sz="1200" dirty="0">
+              <a:solidFill>
+                <a:srgbClr val="475569"/>
+              </a:solidFill>
+              <a:latin typeface="Calibri"/>
+            </a:endParaRPr>
           </a:p>
           <a:p>
             <a:pPr>
@@ -14886,6 +15771,12 @@
               </a:rPr>
               <a:t>Verified faculty member answers; system automatically validates credentials and renders badges: 🏛️ Computer Science &amp; 📚 Cryptography, proving expert authority.</a:t>
             </a:r>
+            <a:endParaRPr sz="1200" dirty="0">
+              <a:solidFill>
+                <a:srgbClr val="475569"/>
+              </a:solidFill>
+              <a:latin typeface="Calibri"/>
+            </a:endParaRPr>
           </a:p>
           <a:p>
             <a:pPr>
@@ -14911,6 +15802,12 @@
               </a:rPr>
               <a:t>If deeper private assistance is required, the student clicks '💬 Message' directly on the faculty's answer to launch an end-to-end encrypted direct chat session.</a:t>
             </a:r>
+            <a:endParaRPr sz="1200" dirty="0">
+              <a:solidFill>
+                <a:srgbClr val="475569"/>
+              </a:solidFill>
+              <a:latin typeface="Calibri"/>
+            </a:endParaRPr>
           </a:p>
           <a:p>
             <a:pPr>
@@ -14954,6 +15851,12 @@
               </a:rPr>
               <a:t>) with block timestamp.</a:t>
             </a:r>
+            <a:endParaRPr sz="1200" dirty="0">
+              <a:solidFill>
+                <a:srgbClr val="475569"/>
+              </a:solidFill>
+              <a:latin typeface="Calibri"/>
+            </a:endParaRPr>
           </a:p>
           <a:p>
             <a:pPr>
@@ -14979,6 +15882,12 @@
               </a:rPr>
               <a:t>Admin or examiner searches student by real institutional credential (Index: UEB3509022 / Email: osei@uenr.edu.gh / Staff: PS001) in the Admin Audit Desk.</a:t>
             </a:r>
+            <a:endParaRPr sz="1200" dirty="0">
+              <a:solidFill>
+                <a:srgbClr val="475569"/>
+              </a:solidFill>
+              <a:latin typeface="Calibri"/>
+            </a:endParaRPr>
           </a:p>
           <a:p>
             <a:pPr>
@@ -15022,6 +15931,12 @@
               </a:rPr>
               <a:t> hash.</a:t>
             </a:r>
+            <a:endParaRPr sz="1200" dirty="0">
+              <a:solidFill>
+                <a:srgbClr val="475569"/>
+              </a:solidFill>
+              <a:latin typeface="Calibri"/>
+            </a:endParaRPr>
           </a:p>
         </p:txBody>
       </p:sp>
@@ -15068,7 +15983,6 @@
           <a:lstStyle/>
           <a:p>
             <a:pPr algn="ctr"/>
-            <a:endParaRPr/>
           </a:p>
         </p:txBody>
       </p:sp>
@@ -15121,6 +16035,12 @@
               </a:rPr>
               <a:t>📸  ADMIN AUDIT DESK &amp; VERIFICATION PROOF MODAL</a:t>
             </a:r>
+            <a:endParaRPr sz="1200" b="1" dirty="0">
+              <a:solidFill>
+                <a:srgbClr val="FFFFFF"/>
+              </a:solidFill>
+              <a:latin typeface="Calibri"/>
+            </a:endParaRPr>
           </a:p>
         </p:txBody>
       </p:sp>
@@ -15156,6 +16076,12 @@
               </a:rPr>
               <a:t>Live Blockchain Timestamp Verification &amp; Tamper Detection Interface</a:t>
             </a:r>
+            <a:endParaRPr sz="1600" b="1" i="1" dirty="0">
+              <a:solidFill>
+                <a:srgbClr val="00509E"/>
+              </a:solidFill>
+              <a:latin typeface="Calibri"/>
+            </a:endParaRPr>
           </a:p>
           <a:p>
             <a:pPr>
@@ -15172,6 +16098,12 @@
               </a:rPr>
               <a:t>• Student Identifier Search: Query index number 'UEB3509022' or staff ID 'PS001'.</a:t>
             </a:r>
+            <a:endParaRPr sz="1400" dirty="0">
+              <a:solidFill>
+                <a:srgbClr val="1E293B"/>
+              </a:solidFill>
+              <a:latin typeface="Calibri"/>
+            </a:endParaRPr>
           </a:p>
           <a:p>
             <a:pPr>
@@ -15206,6 +16138,12 @@
               </a:rPr>
               <a:t> hashes.</a:t>
             </a:r>
+            <a:endParaRPr sz="1400" dirty="0">
+              <a:solidFill>
+                <a:srgbClr val="1E293B"/>
+              </a:solidFill>
+              <a:latin typeface="Calibri"/>
+            </a:endParaRPr>
           </a:p>
           <a:p>
             <a:pPr>
@@ -15222,6 +16160,12 @@
               </a:rPr>
               <a:t>• Cryptographic Audit Trail Modal: Compares database record vs. immutable Besu block record.</a:t>
             </a:r>
+            <a:endParaRPr sz="1400" dirty="0">
+              <a:solidFill>
+                <a:srgbClr val="1E293B"/>
+              </a:solidFill>
+              <a:latin typeface="Calibri"/>
+            </a:endParaRPr>
           </a:p>
           <a:p>
             <a:pPr>
@@ -15238,6 +16182,12 @@
               </a:rPr>
               <a:t>• Certified Verdict Banner: Displays '✅ Authentic Submission' confirmation.</a:t>
             </a:r>
+            <a:endParaRPr sz="1400" dirty="0">
+              <a:solidFill>
+                <a:srgbClr val="1E293B"/>
+              </a:solidFill>
+              <a:latin typeface="Calibri"/>
+            </a:endParaRPr>
           </a:p>
           <a:p>
             <a:pPr>
@@ -15254,6 +16204,12 @@
               </a:rPr>
               <a:t>• Tamper Detection Guarantee: If database record is altered, SHA-256 hash mismatch alerts admin instantly.</a:t>
             </a:r>
+            <a:endParaRPr sz="1400" dirty="0">
+              <a:solidFill>
+                <a:srgbClr val="1E293B"/>
+              </a:solidFill>
+              <a:latin typeface="Calibri"/>
+            </a:endParaRPr>
           </a:p>
         </p:txBody>
       </p:sp>
@@ -15297,7 +16253,6 @@
           <a:lstStyle/>
           <a:p>
             <a:pPr algn="ctr"/>
-            <a:endParaRPr/>
           </a:p>
         </p:txBody>
       </p:sp>
@@ -15341,7 +16296,6 @@
           <a:lstStyle/>
           <a:p>
             <a:pPr algn="ctr"/>
-            <a:endParaRPr/>
           </a:p>
         </p:txBody>
       </p:sp>
@@ -15386,25 +16340,25 @@
               </a:rPr>
               <a:t>Even if a malicious actor alters a database submission timestamp or edits text directly in SQL, the SHA-256 block hash mismatch on Hyperledger Besu immediately exposes the tampering.</a:t>
             </a:r>
+            <a:endParaRPr sz="1200" dirty="0">
+              <a:solidFill>
+                <a:srgbClr val="FFFFFF"/>
+              </a:solidFill>
+              <a:latin typeface="Calibri"/>
+            </a:endParaRPr>
           </a:p>
         </p:txBody>
       </p:sp>
       <p:pic>
         <p:nvPicPr>
-          <p:cNvPr id="19" name="Picture 18">
-            <a:extLst>
-              <a:ext uri="{FF2B5EF4-FFF2-40B4-BE49-F238E27FC236}">
-                <a16:creationId xmlns:a16="http://schemas.microsoft.com/office/drawing/2014/main" id="{C0AD18B5-F76E-30AE-017A-E2E246BA8C2E}"/>
-              </a:ext>
-            </a:extLst>
-          </p:cNvPr>
+          <p:cNvPr id="19" name="Picture 18"/>
           <p:cNvPicPr>
             <a:picLocks noChangeAspect="1"/>
           </p:cNvPicPr>
           <p:nvPr/>
         </p:nvPicPr>
         <p:blipFill>
-          <a:blip r:embed="rId2"/>
+          <a:blip r:embed="rId1"/>
           <a:stretch>
             <a:fillRect/>
           </a:stretch>
@@ -15487,7 +16441,6 @@
           <a:lstStyle/>
           <a:p>
             <a:pPr algn="ctr"/>
-            <a:endParaRPr/>
           </a:p>
         </p:txBody>
       </p:sp>
@@ -15531,7 +16484,6 @@
           <a:lstStyle/>
           <a:p>
             <a:pPr algn="ctr"/>
-            <a:endParaRPr/>
           </a:p>
         </p:txBody>
       </p:sp>
@@ -15575,7 +16527,6 @@
           <a:lstStyle/>
           <a:p>
             <a:pPr algn="ctr"/>
-            <a:endParaRPr/>
           </a:p>
         </p:txBody>
       </p:sp>
@@ -15628,6 +16579,12 @@
               </a:rPr>
               <a:t>07</a:t>
             </a:r>
+            <a:endParaRPr sz="2000" b="1">
+              <a:solidFill>
+                <a:srgbClr val="00336A"/>
+              </a:solidFill>
+              <a:latin typeface="Calibri"/>
+            </a:endParaRPr>
           </a:p>
         </p:txBody>
       </p:sp>
@@ -15662,6 +16619,12 @@
               </a:rPr>
               <a:t>Empirical Results &amp; Live System Demo</a:t>
             </a:r>
+            <a:endParaRPr sz="2000" b="1">
+              <a:solidFill>
+                <a:srgbClr val="FFFFFF"/>
+              </a:solidFill>
+              <a:latin typeface="Calibri"/>
+            </a:endParaRPr>
           </a:p>
           <a:p>
             <a:r>
@@ -15673,6 +16636,12 @@
               </a:rPr>
               <a:t>Empirical Test Suite (100% PASS), System Latency Benchmarks, and Live Feature Demonstration</a:t>
             </a:r>
+            <a:endParaRPr sz="1100" i="1">
+              <a:solidFill>
+                <a:srgbClr val="BAE6FD"/>
+              </a:solidFill>
+              <a:latin typeface="Calibri"/>
+            </a:endParaRPr>
           </a:p>
         </p:txBody>
       </p:sp>
@@ -15716,7 +16685,6 @@
           <a:lstStyle/>
           <a:p>
             <a:pPr algn="ctr"/>
-            <a:endParaRPr/>
           </a:p>
         </p:txBody>
       </p:sp>
@@ -15751,6 +16719,12 @@
               </a:rPr>
               <a:t>QCampus Connect | Verified Academic Q&amp;A Forum &amp; Secure Consultation Platform | Case Study: UENR</a:t>
             </a:r>
+            <a:endParaRPr sz="850">
+              <a:solidFill>
+                <a:srgbClr val="475569"/>
+              </a:solidFill>
+              <a:latin typeface="Calibri"/>
+            </a:endParaRPr>
           </a:p>
         </p:txBody>
       </p:sp>
@@ -15786,6 +16760,12 @@
               </a:rPr>
               <a:t>Slide 07 / 08</a:t>
             </a:r>
+            <a:endParaRPr sz="850" b="1">
+              <a:solidFill>
+                <a:srgbClr val="00336A"/>
+              </a:solidFill>
+              <a:latin typeface="Calibri"/>
+            </a:endParaRPr>
           </a:p>
         </p:txBody>
       </p:sp>
@@ -15831,7 +16811,6 @@
           <a:lstStyle/>
           <a:p>
             <a:pPr algn="ctr"/>
-            <a:endParaRPr/>
           </a:p>
         </p:txBody>
       </p:sp>
@@ -15884,6 +16863,12 @@
               </a:rPr>
               <a:t>Empirical Verification Suite &amp; Benchmarks (100% PASS)</a:t>
             </a:r>
+            <a:endParaRPr sz="1600" b="1" dirty="0">
+              <a:solidFill>
+                <a:srgbClr val="00336A"/>
+              </a:solidFill>
+              <a:latin typeface="Calibri"/>
+            </a:endParaRPr>
           </a:p>
           <a:p>
             <a:pPr>
@@ -15963,6 +16948,12 @@
               </a:rPr>
               <a:t>).</a:t>
             </a:r>
+            <a:endParaRPr sz="1400" dirty="0">
+              <a:solidFill>
+                <a:srgbClr val="475569"/>
+              </a:solidFill>
+              <a:latin typeface="Calibri"/>
+            </a:endParaRPr>
           </a:p>
           <a:p>
             <a:pPr>
@@ -16006,6 +16997,12 @@
               </a:rPr>
               <a:t> (✅ PASS).</a:t>
             </a:r>
+            <a:endParaRPr sz="1400" dirty="0">
+              <a:solidFill>
+                <a:srgbClr val="475569"/>
+              </a:solidFill>
+              <a:latin typeface="Calibri"/>
+            </a:endParaRPr>
           </a:p>
           <a:p>
             <a:pPr>
@@ -16031,6 +17028,12 @@
               </a:rPr>
               <a:t>Payload encryption executed in ~2ms; invalid decryption key throws error (✅ PASS).</a:t>
             </a:r>
+            <a:endParaRPr sz="1400" dirty="0">
+              <a:solidFill>
+                <a:srgbClr val="475569"/>
+              </a:solidFill>
+              <a:latin typeface="Calibri"/>
+            </a:endParaRPr>
           </a:p>
           <a:p>
             <a:pPr>
@@ -16056,6 +17059,12 @@
               </a:rPr>
               <a:t>256-bit sifted key derived in ~12ms; aborts correctly if QBER &gt; 11% (✅ PASS).</a:t>
             </a:r>
+            <a:endParaRPr sz="1400" dirty="0">
+              <a:solidFill>
+                <a:srgbClr val="475569"/>
+              </a:solidFill>
+              <a:latin typeface="Calibri"/>
+            </a:endParaRPr>
           </a:p>
           <a:p>
             <a:pPr>
@@ -16090,6 +17099,12 @@
               </a:rPr>
               <a:t> logs SHA-256 digest; duplicate write reverts; role checks enforced (✅ PASS).</a:t>
             </a:r>
+            <a:endParaRPr sz="1400" dirty="0">
+              <a:solidFill>
+                <a:srgbClr val="475569"/>
+              </a:solidFill>
+              <a:latin typeface="Calibri"/>
+            </a:endParaRPr>
           </a:p>
           <a:p>
             <a:pPr>
@@ -16115,6 +17130,12 @@
               </a:rPr>
               <a:t>WebSocket real-time delivery averaged ~50ms (well under the 200ms target).</a:t>
             </a:r>
+            <a:endParaRPr sz="1400" dirty="0">
+              <a:solidFill>
+                <a:srgbClr val="475569"/>
+              </a:solidFill>
+              <a:latin typeface="Calibri"/>
+            </a:endParaRPr>
           </a:p>
           <a:p>
             <a:pPr>
@@ -16140,6 +17161,12 @@
               </a:rPr>
               <a:t>Asynchronous transaction confirmation in ~0.3–0.5s with zero gas fees.</a:t>
             </a:r>
+            <a:endParaRPr sz="1400" dirty="0">
+              <a:solidFill>
+                <a:srgbClr val="475569"/>
+              </a:solidFill>
+              <a:latin typeface="Calibri"/>
+            </a:endParaRPr>
           </a:p>
         </p:txBody>
       </p:sp>
@@ -16186,7 +17213,6 @@
           <a:lstStyle/>
           <a:p>
             <a:pPr algn="ctr"/>
-            <a:endParaRPr/>
           </a:p>
         </p:txBody>
       </p:sp>
@@ -16239,6 +17265,12 @@
               </a:rPr>
               <a:t>📸  LIVE SYSTEM INTERFACE: Q&amp;A FORUM &amp; DIRECT MESSAGING</a:t>
             </a:r>
+            <a:endParaRPr sz="1200" b="1" dirty="0">
+              <a:solidFill>
+                <a:srgbClr val="FFFFFF"/>
+              </a:solidFill>
+              <a:latin typeface="Calibri"/>
+            </a:endParaRPr>
           </a:p>
         </p:txBody>
       </p:sp>
@@ -16274,6 +17306,12 @@
               </a:rPr>
               <a:t>Panel-Ready Demonstration: Verified Discussions &amp; Private Consultation Flow</a:t>
             </a:r>
+            <a:endParaRPr sz="1600" b="1" i="1" dirty="0">
+              <a:solidFill>
+                <a:srgbClr val="00509E"/>
+              </a:solidFill>
+              <a:latin typeface="Calibri"/>
+            </a:endParaRPr>
           </a:p>
           <a:p>
             <a:pPr>
@@ -16290,6 +17328,12 @@
               </a:rPr>
               <a:t>• Verified Q&amp;A Forum Feed: Questions tagged by Department ('Computer Science') and Topic ('Cryptography').</a:t>
             </a:r>
+            <a:endParaRPr sz="1400" dirty="0">
+              <a:solidFill>
+                <a:srgbClr val="1E293B"/>
+              </a:solidFill>
+              <a:latin typeface="Calibri"/>
+            </a:endParaRPr>
           </a:p>
           <a:p>
             <a:pPr>
@@ -16306,6 +17350,12 @@
               </a:rPr>
               <a:t>• Lecturer Answer View: Verified identity badge (🏛️ CS, 📚 Cryptography) establishing expert authority.</a:t>
             </a:r>
+            <a:endParaRPr sz="1400" dirty="0">
+              <a:solidFill>
+                <a:srgbClr val="1E293B"/>
+              </a:solidFill>
+              <a:latin typeface="Calibri"/>
+            </a:endParaRPr>
           </a:p>
           <a:p>
             <a:pPr>
@@ -16322,6 +17372,12 @@
               </a:rPr>
               <a:t>• Direct Consultation Launch: '💬 Message' button on lecturer's answer seamlessly opens encrypted DM.</a:t>
             </a:r>
+            <a:endParaRPr sz="1400" dirty="0">
+              <a:solidFill>
+                <a:srgbClr val="1E293B"/>
+              </a:solidFill>
+              <a:latin typeface="Calibri"/>
+            </a:endParaRPr>
           </a:p>
           <a:p>
             <a:pPr>
@@ -16338,6 +17394,12 @@
               </a:rPr>
               <a:t>• BB84 Simulation Interface: Live visualization of quantum state transmission, sifting, and error rate check.</a:t>
             </a:r>
+            <a:endParaRPr sz="1400" dirty="0">
+              <a:solidFill>
+                <a:srgbClr val="1E293B"/>
+              </a:solidFill>
+              <a:latin typeface="Calibri"/>
+            </a:endParaRPr>
           </a:p>
           <a:p>
             <a:pPr>
@@ -16354,6 +17416,12 @@
               </a:rPr>
               <a:t>• Verified Student Index: Osei Nana Kwaku (UEB3509022) submission generating live Besu blockchain receipt.</a:t>
             </a:r>
+            <a:endParaRPr sz="1400" dirty="0">
+              <a:solidFill>
+                <a:srgbClr val="1E293B"/>
+              </a:solidFill>
+              <a:latin typeface="Calibri"/>
+            </a:endParaRPr>
           </a:p>
         </p:txBody>
       </p:sp>
@@ -16397,7 +17465,6 @@
           <a:lstStyle/>
           <a:p>
             <a:pPr algn="ctr"/>
-            <a:endParaRPr/>
           </a:p>
         </p:txBody>
       </p:sp>
@@ -16441,7 +17508,6 @@
           <a:lstStyle/>
           <a:p>
             <a:pPr algn="ctr"/>
-            <a:endParaRPr/>
           </a:p>
         </p:txBody>
       </p:sp>
@@ -16486,25 +17552,25 @@
               </a:rPr>
               <a:t>The live demonstration proves that high-speed reactive discussions (&lt;50ms) and permanent blockchain non-repudiation can coexist in a production-ready, zero-error web application.</a:t>
             </a:r>
+            <a:endParaRPr sz="1200" dirty="0">
+              <a:solidFill>
+                <a:srgbClr val="FFFFFF"/>
+              </a:solidFill>
+              <a:latin typeface="Calibri"/>
+            </a:endParaRPr>
           </a:p>
         </p:txBody>
       </p:sp>
       <p:pic>
         <p:nvPicPr>
-          <p:cNvPr id="19" name="Picture 18">
-            <a:extLst>
-              <a:ext uri="{FF2B5EF4-FFF2-40B4-BE49-F238E27FC236}">
-                <a16:creationId xmlns:a16="http://schemas.microsoft.com/office/drawing/2014/main" id="{8CD642D8-7AA4-8FB2-5547-8802E9D8CF4C}"/>
-              </a:ext>
-            </a:extLst>
-          </p:cNvPr>
+          <p:cNvPr id="19" name="Picture 18"/>
           <p:cNvPicPr>
             <a:picLocks noChangeAspect="1"/>
           </p:cNvPicPr>
           <p:nvPr/>
         </p:nvPicPr>
         <p:blipFill>
-          <a:blip r:embed="rId2"/>
+          <a:blip r:embed="rId1"/>
           <a:stretch>
             <a:fillRect/>
           </a:stretch>
@@ -16846,6 +17912,10 @@
       </a:style>
     </a:lnDef>
   </a:objectDefaults>
-  <a:extraClrSchemeLst/>
+  <a:extLst>
+    <a:ext uri="{05A4C25C-085E-4340-85A3-A5531E510DB2}">
+      <thm15:themeFamily xmlns:thm15="http://schemas.microsoft.com/office/thememl/2012/main" name="Office Theme" id="{62F939B6-93AF-4DB8-9C6B-D6C7DFDC589F}" vid="{4A3C46E8-61CC-4603-A589-7422A47A8E4A}"/>
+    </a:ext>
+  </a:extLst>
 </a:theme>
 </file>
</xml_diff>